<commit_message>
Update stable submission materials for Google sign-in, durable cost guards and speaker-model assessment
</commit_message>
<xml_diff>
--- a/docs/submission/LingoLive-Pitch-Deck.pptx
+++ b/docs/submission/LingoLive-Pitch-Deck.pptx
@@ -7226,7 +7226,7 @@
               </a:defRPr>
             </a:pPr>
             <a:r>
-              <a:t>• Host limits: 400 raw model calls/day and 60 audio minutes/day.</a:t>
+              <a:t>• Shared/day: 20 listening minutes + 100 lessons. Reset: midnight IST.</a:t>
             </a:r>
           </a:p>
           <a:p>
@@ -7281,7 +7281,7 @@
               </a:defRPr>
             </a:pPr>
             <a:r>
-              <a:t>Quotas are prototype safeguards, not a hard billing cap. A wider launch needs durable per-user budgets.</a:t>
+              <a:t>Persistent quotas survive restarts; they do not cap all hosting/storage/download charges in currency.</a:t>
             </a:r>
           </a:p>
         </p:txBody>
@@ -8340,7 +8340,7 @@
               </a:defRPr>
             </a:pPr>
             <a:r>
-              <a:t>112 backend tests; real Google replies and current Cloud Run guards verified</a:t>
+              <a:t>134 backend tests; Google-token verification and durable quota races checked</a:t>
             </a:r>
           </a:p>
         </p:txBody>
@@ -8874,7 +8874,7 @@
               </a:defRPr>
             </a:pPr>
             <a:r>
-              <a:t>Durable per-user budgets and stronger identity.</a:t>
+              <a:t>Opt-in local neural voice enrollment and durable per-user budgets.</a:t>
             </a:r>
           </a:p>
           <a:p>
@@ -9369,7 +9369,7 @@
               </a:defRPr>
             </a:pPr>
             <a:r>
-              <a:t>AI access: use your Google key, or obtain the host code privately from the team. No keys or codes are included.</a:t>
+              <a:t>AI access: sign in with any verified Google account; no passcode. Your own Google key is optional.</a:t>
             </a:r>
           </a:p>
         </p:txBody>
@@ -11825,7 +11825,7 @@
               </a:defRPr>
             </a:pPr>
             <a:r>
-              <a:t>Private host code or your own Google key; usage guards.</a:t>
+              <a:t>Google sign-in, no passcode; shared daily limits.</a:t>
             </a:r>
           </a:p>
         </p:txBody>
@@ -14054,7 +14054,7 @@
               </a:defRPr>
             </a:pPr>
             <a:r>
-              <a:t>Host code / personal-key session</a:t>
+              <a:t>Google / personal-key session</a:t>
             </a:r>
           </a:p>
           <a:p>
@@ -14102,7 +14102,7 @@
               </a:defRPr>
             </a:pPr>
             <a:r>
-              <a:t>Secret Manager access code</a:t>
+              <a:t>Private durable daily quotas</a:t>
             </a:r>
           </a:p>
         </p:txBody>
@@ -14406,7 +14406,7 @@
               </a:defRPr>
             </a:pPr>
             <a:r>
-              <a:t>Firebase / Firestore are not used in this prototype. Any future cloud sync would require a separate opt-in design.</a:t>
+              <a:t>Firebase Authentication: Google sign-in. Private Cloud Storage: daily quotas. Firestore is not used; learning stays local.</a:t>
             </a:r>
           </a:p>
         </p:txBody>
@@ -14853,7 +14853,7 @@
               </a:defRPr>
             </a:pPr>
             <a:r>
-              <a:t>Cloud Run, Vertex AI, Secret Manager, Cloud Build and Artifact Registry.</a:t>
+              <a:t>Firebase Authentication, Cloud Run, Vertex AI, private Cloud Storage and Secret Manager.</a:t>
             </a:r>
           </a:p>
         </p:txBody>

</xml_diff>

<commit_message>
Refine Accessibility submission and five-dollar learner cost model
</commit_message>
<xml_diff>
--- a/docs/submission/LingoLive-Pitch-Deck.pptx
+++ b/docs/submission/LingoLive-Pitch-Deck.pptx
@@ -6854,7 +6854,7 @@
               </a:defRPr>
             </a:pPr>
             <a:r>
-              <a:t>Problem: Help immigrants and interstate newcomers respond in an unfamiliar language.</a:t>
+              <a:t>Problem: Help migrants participate in everyday conversations in an unfamiliar language.</a:t>
             </a:r>
           </a:p>
           <a:p>
@@ -6867,7 +6867,7 @@
               </a:defRPr>
             </a:pPr>
             <a:r>
-              <a:t>Theme: Media, Content &amp; Digital Experiences | Category: Education</a:t>
+              <a:t>Theme: Sustainability &amp; Social Impact | Category: Accessibility</a:t>
             </a:r>
           </a:p>
         </p:txBody>
@@ -7091,14 +7091,59 @@
       </p:sp>
       <p:sp>
         <p:nvSpPr>
-          <p:cNvPr id="128" name="TextBox 127"/>
-          <p:cNvSpPr txBox="1"/>
-          <p:nvPr/>
-        </p:nvSpPr>
-        <p:spPr>
-          <a:xfrm>
-            <a:off x="502920" y="1417320"/>
-            <a:ext cx="8046720" cy="457200"/>
+          <p:cNvPr id="128" name="Rounded Rectangle 127"/>
+          <p:cNvSpPr/>
+          <p:nvPr/>
+        </p:nvSpPr>
+        <p:spPr>
+          <a:xfrm>
+            <a:off x="457200" y="1371600"/>
+            <a:ext cx="3977639" cy="1051560"/>
+          </a:xfrm>
+          <a:prstGeom prst="roundRect">
+            <a:avLst/>
+          </a:prstGeom>
+          <a:solidFill>
+            <a:srgbClr val="F1F6FD"/>
+          </a:solidFill>
+          <a:ln>
+            <a:solidFill>
+              <a:srgbClr val="DADCE0"/>
+            </a:solidFill>
+          </a:ln>
+        </p:spPr>
+        <p:style>
+          <a:lnRef idx="1">
+            <a:schemeClr val="accent1"/>
+          </a:lnRef>
+          <a:fillRef idx="3">
+            <a:schemeClr val="accent1"/>
+          </a:fillRef>
+          <a:effectRef idx="2">
+            <a:schemeClr val="accent1"/>
+          </a:effectRef>
+          <a:fontRef idx="minor">
+            <a:schemeClr val="lt1"/>
+          </a:fontRef>
+        </p:style>
+        <p:txBody>
+          <a:bodyPr rtlCol="0" anchor="ctr"/>
+          <a:lstStyle/>
+          <a:p>
+            <a:pPr algn="ctr"/>
+          </a:p>
+        </p:txBody>
+      </p:sp>
+      <p:sp>
+        <p:nvSpPr>
+          <p:cNvPr id="129" name="TextBox 128"/>
+          <p:cNvSpPr txBox="1"/>
+          <p:nvPr/>
+        </p:nvSpPr>
+        <p:spPr>
+          <a:xfrm>
+            <a:off x="576072" y="1463040"/>
+            <a:ext cx="3739896" cy="329184"/>
           </a:xfrm>
           <a:prstGeom prst="rect">
             <a:avLst/>
@@ -7115,7 +7160,46 @@
               <a:spcAft>
                 <a:spcPts val="700"/>
               </a:spcAft>
-              <a:defRPr sz="2100" b="1">
+              <a:defRPr sz="1500" b="1">
+                <a:solidFill>
+                  <a:srgbClr val="1A73E8"/>
+                </a:solidFill>
+                <a:latin typeface="Arial"/>
+              </a:defRPr>
+            </a:pPr>
+            <a:r>
+              <a:t>~US$5 / learner / month · ₹450</a:t>
+            </a:r>
+          </a:p>
+        </p:txBody>
+      </p:sp>
+      <p:sp>
+        <p:nvSpPr>
+          <p:cNvPr id="130" name="TextBox 129"/>
+          <p:cNvSpPr txBox="1"/>
+          <p:nvPr/>
+        </p:nvSpPr>
+        <p:spPr>
+          <a:xfrm>
+            <a:off x="576072" y="1856232"/>
+            <a:ext cx="3739896" cy="530352"/>
+          </a:xfrm>
+          <a:prstGeom prst="rect">
+            <a:avLst/>
+          </a:prstGeom>
+          <a:noFill/>
+        </p:spPr>
+        <p:txBody>
+          <a:bodyPr wrap="square" lIns="54864" rIns="54864" tIns="27432" bIns="0">
+            <a:spAutoFit/>
+          </a:bodyPr>
+          <a:lstStyle/>
+          <a:p>
+            <a:pPr>
+              <a:spcAft>
+                <a:spcPts val="700"/>
+              </a:spcAft>
+              <a:defRPr sz="1300" b="0">
                 <a:solidFill>
                   <a:srgbClr val="202124"/>
                 </a:solidFill>
@@ -7123,21 +7207,144 @@
               </a:defRPr>
             </a:pPr>
             <a:r>
-              <a:t>Cost model: pay for useful turns, bound prototype usage.</a:t>
-            </a:r>
-          </a:p>
-        </p:txBody>
-      </p:sp>
-      <p:sp>
-        <p:nvSpPr>
-          <p:cNvPr id="129" name="TextBox 128"/>
-          <p:cNvSpPr txBox="1"/>
-          <p:nvPr/>
-        </p:nvSpPr>
-        <p:spPr>
-          <a:xfrm>
-            <a:off x="502920" y="2039112"/>
-            <a:ext cx="8046720" cy="2377440"/>
+              <a:t>200 listening minutes + 400 new reply turns per month.</a:t>
+            </a:r>
+          </a:p>
+        </p:txBody>
+      </p:sp>
+      <p:sp>
+        <p:nvSpPr>
+          <p:cNvPr id="131" name="Rounded Rectangle 130"/>
+          <p:cNvSpPr/>
+          <p:nvPr/>
+        </p:nvSpPr>
+        <p:spPr>
+          <a:xfrm>
+            <a:off x="4709160" y="1371600"/>
+            <a:ext cx="3977639" cy="1051560"/>
+          </a:xfrm>
+          <a:prstGeom prst="roundRect">
+            <a:avLst/>
+          </a:prstGeom>
+          <a:solidFill>
+            <a:srgbClr val="F1F6FD"/>
+          </a:solidFill>
+          <a:ln>
+            <a:solidFill>
+              <a:srgbClr val="DADCE0"/>
+            </a:solidFill>
+          </a:ln>
+        </p:spPr>
+        <p:style>
+          <a:lnRef idx="1">
+            <a:schemeClr val="accent1"/>
+          </a:lnRef>
+          <a:fillRef idx="3">
+            <a:schemeClr val="accent1"/>
+          </a:fillRef>
+          <a:effectRef idx="2">
+            <a:schemeClr val="accent1"/>
+          </a:effectRef>
+          <a:fontRef idx="minor">
+            <a:schemeClr val="lt1"/>
+          </a:fontRef>
+        </p:style>
+        <p:txBody>
+          <a:bodyPr rtlCol="0" anchor="ctr"/>
+          <a:lstStyle/>
+          <a:p>
+            <a:pPr algn="ctr"/>
+          </a:p>
+        </p:txBody>
+      </p:sp>
+      <p:sp>
+        <p:nvSpPr>
+          <p:cNvPr id="132" name="TextBox 131"/>
+          <p:cNvSpPr txBox="1"/>
+          <p:nvPr/>
+        </p:nvSpPr>
+        <p:spPr>
+          <a:xfrm>
+            <a:off x="4828032" y="1463040"/>
+            <a:ext cx="3739896" cy="329184"/>
+          </a:xfrm>
+          <a:prstGeom prst="rect">
+            <a:avLst/>
+          </a:prstGeom>
+          <a:noFill/>
+        </p:spPr>
+        <p:txBody>
+          <a:bodyPr wrap="square" lIns="54864" rIns="54864" tIns="27432" bIns="0">
+            <a:spAutoFit/>
+          </a:bodyPr>
+          <a:lstStyle/>
+          <a:p>
+            <a:pPr>
+              <a:spcAft>
+                <a:spcPts val="700"/>
+              </a:spcAft>
+              <a:defRPr sz="1500" b="1">
+                <a:solidFill>
+                  <a:srgbClr val="1A73E8"/>
+                </a:solidFill>
+                <a:latin typeface="Arial"/>
+              </a:defRPr>
+            </a:pPr>
+            <a:r>
+              <a:t>100 learners · ~US$465 / month</a:t>
+            </a:r>
+          </a:p>
+        </p:txBody>
+      </p:sp>
+      <p:sp>
+        <p:nvSpPr>
+          <p:cNvPr id="133" name="TextBox 132"/>
+          <p:cNvSpPr txBox="1"/>
+          <p:nvPr/>
+        </p:nvSpPr>
+        <p:spPr>
+          <a:xfrm>
+            <a:off x="4828032" y="1856232"/>
+            <a:ext cx="3739896" cy="530352"/>
+          </a:xfrm>
+          <a:prstGeom prst="rect">
+            <a:avLst/>
+          </a:prstGeom>
+          <a:noFill/>
+        </p:spPr>
+        <p:txBody>
+          <a:bodyPr wrap="square" lIns="54864" rIns="54864" tIns="27432" bIns="0">
+            <a:spAutoFit/>
+          </a:bodyPr>
+          <a:lstStyle/>
+          <a:p>
+            <a:pPr>
+              <a:spcAft>
+                <a:spcPts val="700"/>
+              </a:spcAft>
+              <a:defRPr sz="1300" b="0">
+                <a:solidFill>
+                  <a:srgbClr val="202124"/>
+                </a:solidFill>
+                <a:latin typeface="Arial"/>
+              </a:defRPr>
+            </a:pPr>
+            <a:r>
+              <a:t>Shared community estimate, including contingency.</a:t>
+            </a:r>
+          </a:p>
+        </p:txBody>
+      </p:sp>
+      <p:sp>
+        <p:nvSpPr>
+          <p:cNvPr id="134" name="TextBox 133"/>
+          <p:cNvSpPr txBox="1"/>
+          <p:nvPr/>
+        </p:nvSpPr>
+        <p:spPr>
+          <a:xfrm>
+            <a:off x="502920" y="2606040"/>
+            <a:ext cx="8138160" cy="521207"/>
           </a:xfrm>
           <a:prstGeom prst="rect">
             <a:avLst/>
@@ -7162,15 +7369,38 @@
               </a:defRPr>
             </a:pPr>
             <a:r>
-              <a:t>• A 15-minute listening session uses up to 15 minutes of streaming audio.</a:t>
-            </a:r>
-          </a:p>
+              <a:t>Per learner: speech $1.79 + generation $1.76 + shared infrastructure $0.30. Add 20% contingency, then round the budget to US$5.</a:t>
+            </a:r>
+          </a:p>
+        </p:txBody>
+      </p:sp>
+      <p:sp>
+        <p:nvSpPr>
+          <p:cNvPr id="135" name="TextBox 134"/>
+          <p:cNvSpPr txBox="1"/>
+          <p:nvPr/>
+        </p:nvSpPr>
+        <p:spPr>
+          <a:xfrm>
+            <a:off x="502920" y="3291840"/>
+            <a:ext cx="8138160" cy="667512"/>
+          </a:xfrm>
+          <a:prstGeom prst="rect">
+            <a:avLst/>
+          </a:prstGeom>
+          <a:noFill/>
+        </p:spPr>
+        <p:txBody>
+          <a:bodyPr wrap="square" lIns="54864" rIns="54864" tIns="27432" bIns="0">
+            <a:spAutoFit/>
+          </a:bodyPr>
+          <a:lstStyle/>
           <a:p>
             <a:pPr>
               <a:spcAft>
                 <a:spcPts val="700"/>
               </a:spcAft>
-              <a:defRPr sz="1500" b="0">
+              <a:defRPr sz="1400" b="0">
                 <a:solidFill>
                   <a:srgbClr val="202124"/>
                 </a:solidFill>
@@ -7178,85 +7408,21 @@
               </a:defRPr>
             </a:pPr>
             <a:r>
-              <a:t>• N new lessons use 2 × N Flash-Lite generation calls.</a:t>
-            </a:r>
-          </a:p>
-          <a:p>
-            <a:pPr>
-              <a:spcAft>
-                <a:spcPts val="700"/>
-              </a:spcAft>
-              <a:defRPr sz="1500" b="0">
-                <a:solidFill>
-                  <a:srgbClr val="202124"/>
-                </a:solidFill>
-                <a:latin typeface="Arial"/>
-              </a:defRPr>
-            </a:pPr>
-            <a:r>
-              <a:t>• Detected repeats, saved word review and script switching add no lesson call.</a:t>
-            </a:r>
-          </a:p>
-          <a:p>
-            <a:pPr>
-              <a:spcAft>
-                <a:spcPts val="700"/>
-              </a:spcAft>
-              <a:defRPr sz="1500" b="0">
-                <a:solidFill>
-                  <a:srgbClr val="202124"/>
-                </a:solidFill>
-                <a:latin typeface="Arial"/>
-              </a:defRPr>
-            </a:pPr>
-            <a:r>
-              <a:t>• Cloud Run: 1 CPU / 512 MiB, request billing, min 0 / max 1 instance.</a:t>
-            </a:r>
-          </a:p>
-          <a:p>
-            <a:pPr>
-              <a:spcAft>
-                <a:spcPts val="700"/>
-              </a:spcAft>
-              <a:defRPr sz="1500" b="0">
-                <a:solidFill>
-                  <a:srgbClr val="202124"/>
-                </a:solidFill>
-                <a:latin typeface="Arial"/>
-              </a:defRPr>
-            </a:pPr>
-            <a:r>
-              <a:t>• Shared/day: 20 listening minutes + 100 lessons. Reset: midnight IST.</a:t>
-            </a:r>
-          </a:p>
-          <a:p>
-            <a:pPr>
-              <a:spcAft>
-                <a:spcPts val="700"/>
-              </a:spcAft>
-              <a:defRPr sz="1500" b="0">
-                <a:solidFill>
-                  <a:srgbClr val="202124"/>
-                </a:solidFill>
-                <a:latin typeface="Arial"/>
-              </a:defRPr>
-            </a:pPr>
-            <a:r>
-              <a:t>• Prices depend on tokens, provider rates and actual runtime; no dollar estimate is asserted.</a:t>
-            </a:r>
-          </a:p>
-        </p:txBody>
-      </p:sp>
-      <p:sp>
-        <p:nvSpPr>
-          <p:cNvPr id="130" name="TextBox 129"/>
-          <p:cNvSpPr txBox="1"/>
-          <p:nvPr/>
-        </p:nvSpPr>
-        <p:spPr>
-          <a:xfrm>
-            <a:off x="502920" y="4526280"/>
-            <a:ext cx="8046720" cy="292608"/>
+              <a:t>Usage estimate: 10 minutes and 20 new reply turns per day, on 20 days per month; hosting shared across 100 active learners. Each turn uses two parallel calls.</a:t>
+            </a:r>
+          </a:p>
+        </p:txBody>
+      </p:sp>
+      <p:sp>
+        <p:nvSpPr>
+          <p:cNvPr id="136" name="TextBox 135"/>
+          <p:cNvSpPr txBox="1"/>
+          <p:nvPr/>
+        </p:nvSpPr>
+        <p:spPr>
+          <a:xfrm>
+            <a:off x="502920" y="4087368"/>
+            <a:ext cx="8138160" cy="603504"/>
           </a:xfrm>
           <a:prstGeom prst="rect">
             <a:avLst/>
@@ -7281,14 +7447,14 @@
               </a:defRPr>
             </a:pPr>
             <a:r>
-              <a:t>Persistent quotas survive restarts; they do not cap all hosting/storage/download charges in currency.</a:t>
-            </a:r>
-          </a:p>
-        </p:txBody>
-      </p:sp>
-      <p:sp>
-        <p:nvSpPr>
-          <p:cNvPr id="131" name="TextBox 130"/>
+              <a:t>Rate basis: Live Transcribe $0.008925/min; Flash-Lite $0.25/M input and $1.50/M output. Standard global rates checked 18 Oct 2026; before tax and credits. INR planning rate: ₹90/US$. Detailed assumptions: technical PDF.</a:t>
+            </a:r>
+          </a:p>
+        </p:txBody>
+      </p:sp>
+      <p:sp>
+        <p:nvSpPr>
+          <p:cNvPr id="137" name="TextBox 136"/>
           <p:cNvSpPr txBox="1"/>
           <p:nvPr/>
         </p:nvSpPr>
@@ -7710,7 +7876,7 @@
               </a:defRPr>
             </a:pPr>
             <a:r>
-              <a:t>Recorded prototype views. Word-review screenshot uses labelled test data; the video includes real Google responses.</a:t>
+              <a:t>Recorded prototype UI; Saved view uses sample lesson data. The demonstration includes real Google AI responses.</a:t>
             </a:r>
           </a:p>
         </p:txBody>
@@ -7924,8 +8090,8 @@
         </p:nvSpPr>
         <p:spPr>
           <a:xfrm>
-            <a:off x="502920" y="1417320"/>
-            <a:ext cx="8046720" cy="457200"/>
+            <a:off x="502920" y="1371600"/>
+            <a:ext cx="8046720" cy="475488"/>
           </a:xfrm>
           <a:prstGeom prst="rect">
             <a:avLst/>
@@ -7950,7 +8116,7 @@
               </a:defRPr>
             </a:pPr>
             <a:r>
-              <a:t>Functional evidence, with clear measurement limits.</a:t>
+              <a:t>Designed for an approximately two-second warm lesson.</a:t>
             </a:r>
           </a:p>
         </p:txBody>
@@ -7989,7 +8155,7 @@
               </a:defRPr>
             </a:pPr>
             <a:r>
-              <a:t>Earlier v1.5 warm HTTP lessons</a:t>
+              <a:t>1.79 s mean · 10 lessons</a:t>
             </a:r>
           </a:p>
         </p:txBody>
@@ -8028,7 +8194,7 @@
               </a:defRPr>
             </a:pPr>
             <a:r>
-              <a:t>10 complete lessons · mean 1.79 s · historical sample</a:t>
+              <a:t>Recorded v1.5 warm hosted run; all complete responses succeeded.</a:t>
             </a:r>
           </a:p>
         </p:txBody>
@@ -8067,7 +8233,7 @@
               </a:defRPr>
             </a:pPr>
             <a:r>
-              <a:t>Later v1.9 typed HTTP checks</a:t>
+              <a:t>2.065 s mean · 4 cases</a:t>
             </a:r>
           </a:p>
         </p:txBody>
@@ -8106,7 +8272,7 @@
               </a:defRPr>
             </a:pPr>
             <a:r>
-              <a:t>4 functional cases · mean 2.065 s · not a latency guarantee</a:t>
+              <a:t>Later v1.9 Kannada task flows: cab, tea, café and station.</a:t>
             </a:r>
           </a:p>
         </p:txBody>
@@ -8145,7 +8311,7 @@
               </a:defRPr>
             </a:pPr>
             <a:r>
-              <a:t>Current readback guard</a:t>
+              <a:t>Parallel critical path</a:t>
             </a:r>
           </a:p>
         </p:txBody>
@@ -8184,7 +8350,7 @@
               </a:defRPr>
             </a:pPr>
             <a:r>
-              <a:t>25 local checks + 10 browser-flow checks; repeats add no lesson</a:t>
+              <a:t>Source understanding and replies run together; compact output and warm HTTP.</a:t>
             </a:r>
           </a:p>
         </p:txBody>
@@ -8223,7 +8389,7 @@
               </a:defRPr>
             </a:pPr>
             <a:r>
-              <a:t>Voice estimates</a:t>
+              <a:t>Local reuse</a:t>
             </a:r>
           </a:p>
         </p:txBody>
@@ -8262,7 +8428,7 @@
               </a:defRPr>
             </a:pPr>
             <a:r>
-              <a:t>3/4 held-out clean synthetic learner clips recognized; 0/4 others labelled user</a:t>
+              <a:t>Readbacks preserve replies; word taps and saved review reuse lesson data.</a:t>
             </a:r>
           </a:p>
         </p:txBody>
@@ -8301,7 +8467,7 @@
               </a:defRPr>
             </a:pPr>
             <a:r>
-              <a:t>Service checks</a:t>
+              <a:t>Memory and access checks</a:t>
             </a:r>
           </a:p>
         </p:txBody>
@@ -8340,7 +8506,7 @@
               </a:defRPr>
             </a:pPr>
             <a:r>
-              <a:t>134 backend tests; Google-token verification and durable quota races checked</a:t>
+              <a:t>134 backend tests; 16 place-core checks and 8 place browser flows.</a:t>
             </a:r>
           </a:p>
         </p:txBody>
@@ -8353,7 +8519,7 @@
         </p:nvSpPr>
         <p:spPr>
           <a:xfrm>
-            <a:off x="502920" y="4526280"/>
+            <a:off x="502920" y="4553712"/>
             <a:ext cx="8138160" cy="274320"/>
           </a:xfrm>
           <a:prstGeom prst="rect">
@@ -8379,7 +8545,7 @@
               </a:defRPr>
             </a:pPr>
             <a:r>
-              <a:t>No measured learning-outcome, noisy-phone, cold-start or population speaker-accuracy claim.</a:t>
+              <a:t>Timings measure warm lesson requests; speech also includes transcription finalization and device/network time.</a:t>
             </a:r>
           </a:p>
         </p:txBody>
@@ -8593,7 +8759,7 @@
         </p:nvSpPr>
         <p:spPr>
           <a:xfrm>
-            <a:off x="457200" y="1463040"/>
+            <a:off x="457200" y="1417320"/>
             <a:ext cx="3977639" cy="2697480"/>
           </a:xfrm>
           <a:prstGeom prst="roundRect">
@@ -8638,7 +8804,7 @@
         </p:nvSpPr>
         <p:spPr>
           <a:xfrm>
-            <a:off x="576072" y="1554480"/>
+            <a:off x="576072" y="1508760"/>
             <a:ext cx="3739896" cy="329184"/>
           </a:xfrm>
           <a:prstGeom prst="rect">
@@ -8664,7 +8830,7 @@
               </a:defRPr>
             </a:pPr>
             <a:r>
-              <a:t>Social value and business case</a:t>
+              <a:t>Adoption and business estimates</a:t>
             </a:r>
           </a:p>
         </p:txBody>
@@ -8677,7 +8843,7 @@
         </p:nvSpPr>
         <p:spPr>
           <a:xfrm>
-            <a:off x="576072" y="1947672"/>
+            <a:off x="576072" y="1901952"/>
             <a:ext cx="3739896" cy="2176272"/>
           </a:xfrm>
           <a:prstGeom prst="rect">
@@ -8703,7 +8869,7 @@
               </a:defRPr>
             </a:pPr>
             <a:r>
-              <a:t>Help newcomers participate in everyday encounters.</a:t>
+              <a:t>20 partners × 100 learners = 2,000 learners.</a:t>
             </a:r>
           </a:p>
           <a:p>
@@ -8719,7 +8885,7 @@
               </a:defRPr>
             </a:pPr>
             <a:r>
-              <a:t>Pilot with relocation teams, universities and community language groups.</a:t>
+              <a:t>Community-sponsored usage packages.</a:t>
             </a:r>
           </a:p>
           <a:p>
@@ -8735,7 +8901,23 @@
               </a:defRPr>
             </a:pPr>
             <a:r>
-              <a:t>Proposed organization-sponsored access; validate demand before expansion.</a:t>
+              <a:t>Estimated operating budget: ~US$5 / active learner / month in a 100-member community.</a:t>
+            </a:r>
+          </a:p>
+          <a:p>
+            <a:pPr>
+              <a:spcAft>
+                <a:spcPts val="700"/>
+              </a:spcAft>
+              <a:defRPr sz="1300" b="0">
+                <a:solidFill>
+                  <a:srgbClr val="202124"/>
+                </a:solidFill>
+                <a:latin typeface="Arial"/>
+              </a:defRPr>
+            </a:pPr>
+            <a:r>
+              <a:t>Partners: migrant groups, NGOs, campuses and employers globally.</a:t>
             </a:r>
           </a:p>
         </p:txBody>
@@ -8748,7 +8930,7 @@
         </p:nvSpPr>
         <p:spPr>
           <a:xfrm>
-            <a:off x="4709160" y="1463040"/>
+            <a:off x="4709160" y="1417320"/>
             <a:ext cx="3977639" cy="2697480"/>
           </a:xfrm>
           <a:prstGeom prst="roundRect">
@@ -8793,7 +8975,7 @@
         </p:nvSpPr>
         <p:spPr>
           <a:xfrm>
-            <a:off x="4828032" y="1554480"/>
+            <a:off x="4828032" y="1508760"/>
             <a:ext cx="3739896" cy="329184"/>
           </a:xfrm>
           <a:prstGeom prst="rect">
@@ -8819,7 +9001,7 @@
               </a:defRPr>
             </a:pPr>
             <a:r>
-              <a:t>Next engineering work</a:t>
+              <a:t>Pilot targets and next delivery</a:t>
             </a:r>
           </a:p>
         </p:txBody>
@@ -8832,7 +9014,7 @@
         </p:nvSpPr>
         <p:spPr>
           <a:xfrm>
-            <a:off x="4828032" y="1947672"/>
+            <a:off x="4828032" y="1901952"/>
             <a:ext cx="3739896" cy="2176272"/>
           </a:xfrm>
           <a:prstGeom prst="rect">
@@ -8858,7 +9040,7 @@
               </a:defRPr>
             </a:pPr>
             <a:r>
-              <a:t>Representative mobile/noisy-language studies.</a:t>
+              <a:t>Four weeks, 50 learners: ~1,600 encounters and 8,000 assisted turns.</a:t>
             </a:r>
           </a:p>
           <a:p>
@@ -8874,7 +9056,7 @@
               </a:defRPr>
             </a:pPr>
             <a:r>
-              <a:t>Opt-in local neural voice enrollment and durable per-user budgets.</a:t>
+              <a:t>Targets: 70% useful reply sets; 80% task completion.</a:t>
             </a:r>
           </a:p>
           <a:p>
@@ -8890,23 +9072,7 @@
               </a:defRPr>
             </a:pPr>
             <a:r>
-              <a:t>Opt-in cross-device memory, potentially Firestore.</a:t>
-            </a:r>
-          </a:p>
-          <a:p>
-            <a:pPr>
-              <a:spcAft>
-                <a:spcPts val="700"/>
-              </a:spcAft>
-              <a:defRPr sz="1300" b="0">
-                <a:solidFill>
-                  <a:srgbClr val="202124"/>
-                </a:solidFill>
-                <a:latin typeface="Arial"/>
-              </a:defRPr>
-            </a:pPr>
-            <a:r>
-              <a:t>Measure task completion, reply usefulness and learning retention.</a:t>
+              <a:t>Next: more language pairs, partner allowances and opt-in local voice enrollment.</a:t>
             </a:r>
           </a:p>
         </p:txBody>
@@ -8919,8 +9085,8 @@
         </p:nvSpPr>
         <p:spPr>
           <a:xfrm>
-            <a:off x="502920" y="4462272"/>
-            <a:ext cx="8138160" cy="320040"/>
+            <a:off x="502920" y="4407408"/>
+            <a:ext cx="8138160" cy="384048"/>
           </a:xfrm>
           <a:prstGeom prst="rect">
             <a:avLst/>
@@ -8945,7 +9111,7 @@
               </a:defRPr>
             </a:pPr>
             <a:r>
-              <a:t>Current limits: ASR can mishear; voice estimates can be wrong; local profiles are not private cloud accounts.</a:t>
+              <a:t>Adoption, pilot outcomes and unit economics are planning estimates/targets; assumptions and scale scenario are in the technical PDF.</a:t>
             </a:r>
           </a:p>
         </p:txBody>
@@ -9230,7 +9396,7 @@
               <a:rPr>
                 <a:hlinkClick r:id="rId6"/>
               </a:rPr>
-              <a:t>Demo video — 3–4 minute working demonstration</a:t>
+              <a:t>Demo video — 3:17 working demonstration</a:t>
             </a:r>
           </a:p>
         </p:txBody>
@@ -9353,7 +9519,7 @@
               </a:defRPr>
             </a:pPr>
             <a:r>
-              <a:t>Keep the source repository publicly accessible throughout evaluation.</a:t>
+              <a:t>Sign in with any verified Google account. A personal Google model key is optional.</a:t>
             </a:r>
           </a:p>
           <a:p>
@@ -9369,7 +9535,7 @@
               </a:defRPr>
             </a:pPr>
             <a:r>
-              <a:t>AI access: sign in with any verified Google account; no passcode. Your own Google key is optional.</a:t>
+              <a:t>Shared daily demo allowance: 20 listening minutes and 100 two-branch lessons; midnight IST reset.</a:t>
             </a:r>
           </a:p>
         </p:txBody>
@@ -9636,8 +9802,8 @@
         </p:nvSpPr>
         <p:spPr>
           <a:xfrm>
-            <a:off x="457200" y="1389888"/>
-            <a:ext cx="8138160" cy="640080"/>
+            <a:off x="457200" y="1353312"/>
+            <a:ext cx="8138160" cy="594360"/>
           </a:xfrm>
           <a:prstGeom prst="rect">
             <a:avLst/>
@@ -9654,7 +9820,7 @@
               <a:spcAft>
                 <a:spcPts val="700"/>
               </a:spcAft>
-              <a:defRPr sz="3000" b="1">
+              <a:defRPr sz="2500" b="1">
                 <a:solidFill>
                   <a:srgbClr val="202124"/>
                 </a:solidFill>
@@ -9662,7 +9828,7 @@
               </a:defRPr>
             </a:pPr>
             <a:r>
-              <a:t>Find your words in a new city.</a:t>
+              <a:t>A conversation assistant for life in a new place.</a:t>
             </a:r>
           </a:p>
         </p:txBody>
@@ -9675,8 +9841,8 @@
         </p:nvSpPr>
         <p:spPr>
           <a:xfrm>
-            <a:off x="457200" y="2157984"/>
-            <a:ext cx="8138160" cy="768096"/>
+            <a:off x="457200" y="2011680"/>
+            <a:ext cx="8138160" cy="960120"/>
           </a:xfrm>
           <a:prstGeom prst="rect">
             <a:avLst/>
@@ -9701,7 +9867,7 @@
               </a:defRPr>
             </a:pPr>
             <a:r>
-              <a:t>A newcomer in Bengaluru needs to answer a cab driver in Kannada. LingoLive helps them understand, choose a reply and say it aloud.</a:t>
+              <a:t>LingoLive listens to another person, explains their words and offers three useful replies in the local language, with pronunciation. Plans, recent turns and location-linked memory make those replies personal.</a:t>
             </a:r>
           </a:p>
         </p:txBody>
@@ -9715,7 +9881,7 @@
         <p:spPr>
           <a:xfrm>
             <a:off x="502920" y="3246120"/>
-            <a:ext cx="2514600" cy="1143000"/>
+            <a:ext cx="2514600" cy="1188720"/>
           </a:xfrm>
           <a:prstGeom prst="roundRect">
             <a:avLst/>
@@ -9785,7 +9951,7 @@
               </a:defRPr>
             </a:pPr>
             <a:r>
-              <a:t>Understand</a:t>
+              <a:t>Understand now</a:t>
             </a:r>
           </a:p>
         </p:txBody>
@@ -9799,7 +9965,7 @@
         <p:spPr>
           <a:xfrm>
             <a:off x="621792" y="3730752"/>
-            <a:ext cx="2276856" cy="621792"/>
+            <a:ext cx="2276856" cy="667512"/>
           </a:xfrm>
           <a:prstGeom prst="rect">
             <a:avLst/>
@@ -9824,7 +9990,7 @@
               </a:defRPr>
             </a:pPr>
             <a:r>
-              <a:t>Live multilingual speech → meaning</a:t>
+              <a:t>Live speech → familiar-language meaning</a:t>
             </a:r>
           </a:p>
         </p:txBody>
@@ -9838,7 +10004,7 @@
         <p:spPr>
           <a:xfrm>
             <a:off x="3337560" y="3246120"/>
-            <a:ext cx="2514600" cy="1143000"/>
+            <a:ext cx="2514600" cy="1188720"/>
           </a:xfrm>
           <a:prstGeom prst="roundRect">
             <a:avLst/>
@@ -9908,7 +10074,7 @@
               </a:defRPr>
             </a:pPr>
             <a:r>
-              <a:t>Reply</a:t>
+              <a:t>Reply confidently</a:t>
             </a:r>
           </a:p>
         </p:txBody>
@@ -9922,7 +10088,7 @@
         <p:spPr>
           <a:xfrm>
             <a:off x="3456432" y="3730752"/>
-            <a:ext cx="2276856" cy="621792"/>
+            <a:ext cx="2276856" cy="667512"/>
           </a:xfrm>
           <a:prstGeom prst="rect">
             <a:avLst/>
@@ -9947,7 +10113,7 @@
               </a:defRPr>
             </a:pPr>
             <a:r>
-              <a:t>Useful options + pronunciation</a:t>
+              <a:t>Relevant options + pronunciation</a:t>
             </a:r>
           </a:p>
         </p:txBody>
@@ -9961,7 +10127,7 @@
         <p:spPr>
           <a:xfrm>
             <a:off x="6172200" y="3246120"/>
-            <a:ext cx="2514600" cy="1143000"/>
+            <a:ext cx="2514600" cy="1188720"/>
           </a:xfrm>
           <a:prstGeom prst="roundRect">
             <a:avLst/>
@@ -10031,7 +10197,7 @@
               </a:defRPr>
             </a:pPr>
             <a:r>
-              <a:t>Learn later</a:t>
+              <a:t>Learn afterwards</a:t>
             </a:r>
           </a:p>
         </p:txBody>
@@ -10045,7 +10211,7 @@
         <p:spPr>
           <a:xfrm>
             <a:off x="6291072" y="3730752"/>
-            <a:ext cx="2276856" cy="621792"/>
+            <a:ext cx="2276856" cy="667512"/>
           </a:xfrm>
           <a:prstGeom prst="rect">
             <a:avLst/>
@@ -10070,7 +10236,7 @@
               </a:defRPr>
             </a:pPr>
             <a:r>
-              <a:t>Saved words and personal practice</a:t>
+              <a:t>Saved exchanges → personal practice</a:t>
             </a:r>
           </a:p>
         </p:txBody>
@@ -10284,8 +10450,8 @@
         </p:nvSpPr>
         <p:spPr>
           <a:xfrm>
-            <a:off x="457200" y="1417320"/>
-            <a:ext cx="8229600" cy="914400"/>
+            <a:off x="457200" y="1371600"/>
+            <a:ext cx="8229600" cy="960120"/>
           </a:xfrm>
           <a:prstGeom prst="roundRect">
             <a:avLst/>
@@ -10329,7 +10495,7 @@
         </p:nvSpPr>
         <p:spPr>
           <a:xfrm>
-            <a:off x="576072" y="1508760"/>
+            <a:off x="576072" y="1463040"/>
             <a:ext cx="7991856" cy="329184"/>
           </a:xfrm>
           <a:prstGeom prst="rect">
@@ -10355,7 +10521,7 @@
               </a:defRPr>
             </a:pPr>
             <a:r>
-              <a:t>How is it different?</a:t>
+              <a:t>The problem: understanding is only half the conversation</a:t>
             </a:r>
           </a:p>
         </p:txBody>
@@ -10368,8 +10534,8 @@
         </p:nvSpPr>
         <p:spPr>
           <a:xfrm>
-            <a:off x="576072" y="1901952"/>
-            <a:ext cx="7991856" cy="393192"/>
+            <a:off x="576072" y="1856232"/>
+            <a:ext cx="7991856" cy="438912"/>
           </a:xfrm>
           <a:prstGeom prst="rect">
             <a:avLst/>
@@ -10394,7 +10560,7 @@
               </a:defRPr>
             </a:pPr>
             <a:r>
-              <a:t>Connects the next turn, a pre-task plan, relevant personal/place memory, and later learning in one small interface.</a:t>
+              <a:t>A newcomer must also decide what to say, pronounce it and complete a task while the other person waits.</a:t>
             </a:r>
           </a:p>
         </p:txBody>
@@ -10408,7 +10574,7 @@
         <p:spPr>
           <a:xfrm>
             <a:off x="457200" y="2487168"/>
-            <a:ext cx="8229600" cy="914400"/>
+            <a:ext cx="8229600" cy="960120"/>
           </a:xfrm>
           <a:prstGeom prst="roundRect">
             <a:avLst/>
@@ -10478,7 +10644,7 @@
               </a:defRPr>
             </a:pPr>
             <a:r>
-              <a:t>How does it solve the problem?</a:t>
+              <a:t>The solution: replies that fit the person and the moment</a:t>
             </a:r>
           </a:p>
         </p:txBody>
@@ -10492,7 +10658,7 @@
         <p:spPr>
           <a:xfrm>
             <a:off x="576072" y="2971800"/>
-            <a:ext cx="7991856" cy="393192"/>
+            <a:ext cx="7991856" cy="438912"/>
           </a:xfrm>
           <a:prstGeom prst="rect">
             <a:avLst/>
@@ -10517,7 +10683,7 @@
               </a:defRPr>
             </a:pPr>
             <a:r>
-              <a:t>Prioritizes usable replies during the encounter; the learner reviews word meanings afterwards. Repeated replies do not become new questions.</a:t>
+              <a:t>Combines the current turn, a pre-task plan, activities, preferences and nearby saved-place notes. Learner readbacks update context.</a:t>
             </a:r>
           </a:p>
         </p:txBody>
@@ -10530,8 +10696,8 @@
         </p:nvSpPr>
         <p:spPr>
           <a:xfrm>
-            <a:off x="457200" y="3557016"/>
-            <a:ext cx="8229600" cy="960120"/>
+            <a:off x="457200" y="3602736"/>
+            <a:ext cx="8229600" cy="1005840"/>
           </a:xfrm>
           <a:prstGeom prst="roundRect">
             <a:avLst/>
@@ -10575,7 +10741,7 @@
         </p:nvSpPr>
         <p:spPr>
           <a:xfrm>
-            <a:off x="576072" y="3648456"/>
+            <a:off x="576072" y="3694176"/>
             <a:ext cx="7991856" cy="329184"/>
           </a:xfrm>
           <a:prstGeom prst="rect">
@@ -10601,7 +10767,7 @@
               </a:defRPr>
             </a:pPr>
             <a:r>
-              <a:t>USP and intended users</a:t>
+              <a:t>Users and customers across regions</a:t>
             </a:r>
           </a:p>
         </p:txBody>
@@ -10614,8 +10780,8 @@
         </p:nvSpPr>
         <p:spPr>
           <a:xfrm>
-            <a:off x="576072" y="4041648"/>
-            <a:ext cx="7991856" cy="438912"/>
+            <a:off x="576072" y="4087368"/>
+            <a:ext cx="7991856" cy="484632"/>
           </a:xfrm>
           <a:prstGeom prst="rect">
             <a:avLst/>
@@ -10640,7 +10806,7 @@
               </a:defRPr>
             </a:pPr>
             <a:r>
-              <a:t>Local, editable context follows the learner. Initial pilots: relocation teams, universities and community language groups. Outcomes and demand are not yet measured.</a:t>
+              <a:t>Interstate and international migrants. Customers: migrant associations, NGOs, universities, employers and relocation teams anywhere.</a:t>
             </a:r>
           </a:p>
         </p:txBody>
@@ -10964,7 +11130,7 @@
               </a:defRPr>
             </a:pPr>
             <a:r>
-              <a:t>Google multilingual transcription; three short replies.</a:t>
+              <a:t>Live multilingual speech; three contextual replies.</a:t>
             </a:r>
           </a:p>
         </p:txBody>
@@ -11087,7 +11253,7 @@
               </a:defRPr>
             </a:pPr>
             <a:r>
-              <a:t>Express familiar-language intent in the learning language.</a:t>
+              <a:t>Express familiar-language intent in the local language.</a:t>
             </a:r>
           </a:p>
         </p:txBody>
@@ -11171,7 +11337,7 @@
               </a:defRPr>
             </a:pPr>
             <a:r>
-              <a:t>Recognize readbacks</a:t>
+              <a:t>Recognize learner readbacks</a:t>
             </a:r>
           </a:p>
         </p:txBody>
@@ -11210,7 +11376,7 @@
               </a:defRPr>
             </a:pPr>
             <a:r>
-              <a:t>Fuzzy repeat guards + session voice estimates; correction.</a:t>
+              <a:t>Forgiving repeat matching + session voice estimates.</a:t>
             </a:r>
           </a:p>
         </p:txBody>
@@ -11333,7 +11499,7 @@
               </a:defRPr>
             </a:pPr>
             <a:r>
-              <a:t>Cab → optional tea → station; explicit progress controls.</a:t>
+              <a:t>Cab → optional tea → station; Done / Skip / Previous.</a:t>
             </a:r>
           </a:p>
         </p:txBody>
@@ -11417,7 +11583,7 @@
               </a:defRPr>
             </a:pPr>
             <a:r>
-              <a:t>Relevant memory</a:t>
+              <a:t>Location-linked memory</a:t>
             </a:r>
           </a:p>
         </p:txBody>
@@ -11456,7 +11622,7 @@
               </a:defRPr>
             </a:pPr>
             <a:r>
-              <a:t>Editable routines; opt-in saved-place notes on return.</a:t>
+              <a:t>Opt-in place facts recalled on a fresh return nearby.</a:t>
             </a:r>
           </a:p>
         </p:txBody>
@@ -11540,7 +11706,7 @@
               </a:defRPr>
             </a:pPr>
             <a:r>
-              <a:t>Learn afterwards</a:t>
+              <a:t>Personal memory</a:t>
             </a:r>
           </a:p>
         </p:txBody>
@@ -11579,7 +11745,7 @@
               </a:defRPr>
             </a:pPr>
             <a:r>
-              <a:t>Saved review, word bubbles and pronunciation.</a:t>
+              <a:t>Editable activities and preferences; relevant retrieval.</a:t>
             </a:r>
           </a:p>
         </p:txBody>
@@ -11663,7 +11829,7 @@
               </a:defRPr>
             </a:pPr>
             <a:r>
-              <a:t>Minimal interface</a:t>
+              <a:t>Learn afterwards</a:t>
             </a:r>
           </a:p>
         </p:txBody>
@@ -11702,7 +11868,7 @@
               </a:defRPr>
             </a:pPr>
             <a:r>
-              <a:t>One large microphone control; typing and first-use tutorial.</a:t>
+              <a:t>Saved exchanges; word bubbles and pronunciation.</a:t>
             </a:r>
           </a:p>
         </p:txBody>
@@ -11786,7 +11952,7 @@
               </a:defRPr>
             </a:pPr>
             <a:r>
-              <a:t>Bounded access</a:t>
+              <a:t>Simple, guarded access</a:t>
             </a:r>
           </a:p>
         </p:txBody>
@@ -11825,7 +11991,7 @@
               </a:defRPr>
             </a:pPr>
             <a:r>
-              <a:t>Google sign-in, no passcode; shared daily limits.</a:t>
+              <a:t>One large microphone control; Google sign-in; quotas.</a:t>
             </a:r>
           </a:p>
         </p:txBody>
@@ -12040,7 +12206,7 @@
         <p:spPr>
           <a:xfrm>
             <a:off x="457200" y="1417320"/>
-            <a:ext cx="2377440" cy="1143000"/>
+            <a:ext cx="2377440" cy="1188720"/>
           </a:xfrm>
           <a:prstGeom prst="roundRect">
             <a:avLst/>
@@ -12110,7 +12276,7 @@
               </a:defRPr>
             </a:pPr>
             <a:r>
-              <a:t>1. Listen</a:t>
+              <a:t>1. Plan + listen</a:t>
             </a:r>
           </a:p>
         </p:txBody>
@@ -12124,7 +12290,7 @@
         <p:spPr>
           <a:xfrm>
             <a:off x="576072" y="1901952"/>
-            <a:ext cx="2139696" cy="621792"/>
+            <a:ext cx="2139696" cy="667512"/>
           </a:xfrm>
           <a:prstGeom prst="rect">
             <a:avLst/>
@@ -12149,7 +12315,7 @@
               </a:defRPr>
             </a:pPr>
             <a:r>
-              <a:t>16 kHz browser microphone</a:t>
+              <a:t>Optional goal; one large microphone button</a:t>
             </a:r>
           </a:p>
         </p:txBody>
@@ -12163,7 +12329,7 @@
         <p:spPr>
           <a:xfrm>
             <a:off x="3383280" y="1417320"/>
-            <a:ext cx="2377440" cy="1143000"/>
+            <a:ext cx="2377440" cy="1188720"/>
           </a:xfrm>
           <a:prstGeom prst="roundRect">
             <a:avLst/>
@@ -12233,7 +12399,7 @@
               </a:defRPr>
             </a:pPr>
             <a:r>
-              <a:t>2. Transcribe</a:t>
+              <a:t>2. Understand</a:t>
             </a:r>
           </a:p>
         </p:txBody>
@@ -12247,7 +12413,7 @@
         <p:spPr>
           <a:xfrm>
             <a:off x="3502152" y="1901952"/>
-            <a:ext cx="2139696" cy="621792"/>
+            <a:ext cx="2139696" cy="667512"/>
           </a:xfrm>
           <a:prstGeom prst="rect">
             <a:avLst/>
@@ -12272,7 +12438,7 @@
               </a:defRPr>
             </a:pPr>
             <a:r>
-              <a:t>Gemini Transcribe Live</a:t>
+              <a:t>Live Transcribe produces committed speech</a:t>
             </a:r>
           </a:p>
         </p:txBody>
@@ -12286,7 +12452,7 @@
         <p:spPr>
           <a:xfrm>
             <a:off x="6309360" y="1417320"/>
-            <a:ext cx="2377440" cy="1143000"/>
+            <a:ext cx="2377440" cy="1188720"/>
           </a:xfrm>
           <a:prstGeom prst="roundRect">
             <a:avLst/>
@@ -12370,7 +12536,7 @@
         <p:spPr>
           <a:xfrm>
             <a:off x="6428232" y="1901952"/>
-            <a:ext cx="2139696" cy="621792"/>
+            <a:ext cx="2139696" cy="667512"/>
           </a:xfrm>
           <a:prstGeom prst="rect">
             <a:avLst/>
@@ -12395,7 +12561,7 @@
               </a:defRPr>
             </a:pPr>
             <a:r>
-              <a:t>Text/voice repeat estimates</a:t>
+              <a:t>Readback matching + recent voice clues</a:t>
             </a:r>
           </a:p>
         </p:txBody>
@@ -12487,7 +12653,7 @@
         <p:spPr>
           <a:xfrm>
             <a:off x="457200" y="2926080"/>
-            <a:ext cx="3977639" cy="1234440"/>
+            <a:ext cx="3977639" cy="1325880"/>
           </a:xfrm>
           <a:prstGeom prst="roundRect">
             <a:avLst/>
@@ -12557,7 +12723,7 @@
               </a:defRPr>
             </a:pPr>
             <a:r>
-              <a:t>Your repeated words</a:t>
+              <a:t>Learner repeats a suggested reply</a:t>
             </a:r>
           </a:p>
         </p:txBody>
@@ -12571,7 +12737,7 @@
         <p:spPr>
           <a:xfrm>
             <a:off x="576072" y="3410712"/>
-            <a:ext cx="3739896" cy="713232"/>
+            <a:ext cx="3739896" cy="804672"/>
           </a:xfrm>
           <a:prstGeom prst="rect">
             <a:avLst/>
@@ -12596,7 +12762,7 @@
               </a:defRPr>
             </a:pPr>
             <a:r>
-              <a:t>Keep in local conversation context. Wait for the other speaker. Uncertain meaning → confirm the speaker.</a:t>
+              <a:t>Keep the actual spoken words in context and preserve the options. Continue listening for the other person.</a:t>
             </a:r>
           </a:p>
         </p:txBody>
@@ -12610,7 +12776,7 @@
         <p:spPr>
           <a:xfrm>
             <a:off x="4709160" y="2926080"/>
-            <a:ext cx="3977639" cy="1234440"/>
+            <a:ext cx="3977639" cy="1325880"/>
           </a:xfrm>
           <a:prstGeom prst="roundRect">
             <a:avLst/>
@@ -12680,7 +12846,7 @@
               </a:defRPr>
             </a:pPr>
             <a:r>
-              <a:t>Other / unknown turn</a:t>
+              <a:t>A new turn needs assistance</a:t>
             </a:r>
           </a:p>
         </p:txBody>
@@ -12694,7 +12860,7 @@
         <p:spPr>
           <a:xfrm>
             <a:off x="4828032" y="3410712"/>
-            <a:ext cx="3739896" cy="713232"/>
+            <a:ext cx="3739896" cy="804672"/>
           </a:xfrm>
           <a:prstGeom prst="rect">
             <a:avLst/>
@@ -12719,7 +12885,7 @@
               </a:defRPr>
             </a:pPr>
             <a:r>
-              <a:t>Two Flash-Lite branches → meaning + replies → learner speaks → Saved learning later.</a:t>
+              <a:t>Parallel Flash-Lite tasks → meaning + three replies → learner speaks → Saved review afterwards.</a:t>
             </a:r>
           </a:p>
         </p:txBody>
@@ -12732,8 +12898,8 @@
         </p:nvSpPr>
         <p:spPr>
           <a:xfrm>
-            <a:off x="502920" y="4407408"/>
-            <a:ext cx="8138160" cy="320040"/>
+            <a:off x="502920" y="4443984"/>
+            <a:ext cx="8138160" cy="274320"/>
           </a:xfrm>
           <a:prstGeom prst="rect">
             <a:avLst/>
@@ -12758,7 +12924,7 @@
               </a:defRPr>
             </a:pPr>
             <a:r>
-              <a:t>Speaker estimates help routing; they are not reliable identity. Explicit correction always wins.</a:t>
+              <a:t>The learner can correct who spoke. Goals, plan progress and relevant place memories follow the conversation.</a:t>
             </a:r>
           </a:p>
         </p:txBody>
@@ -12966,575 +13132,7 @@
       </p:sp>
       <p:sp>
         <p:nvSpPr>
-          <p:cNvPr id="104" name="Rounded Rectangle 103"/>
-          <p:cNvSpPr/>
-          <p:nvPr/>
-        </p:nvSpPr>
-        <p:spPr>
-          <a:xfrm>
-            <a:off x="457200" y="1508760"/>
-            <a:ext cx="2468880" cy="2560320"/>
-          </a:xfrm>
-          <a:prstGeom prst="roundRect">
-            <a:avLst/>
-          </a:prstGeom>
-          <a:solidFill>
-            <a:srgbClr val="F1F6FD"/>
-          </a:solidFill>
-          <a:ln>
-            <a:solidFill>
-              <a:srgbClr val="DADCE0"/>
-            </a:solidFill>
-          </a:ln>
-        </p:spPr>
-        <p:style>
-          <a:lnRef idx="1">
-            <a:schemeClr val="accent1"/>
-          </a:lnRef>
-          <a:fillRef idx="3">
-            <a:schemeClr val="accent1"/>
-          </a:fillRef>
-          <a:effectRef idx="2">
-            <a:schemeClr val="accent1"/>
-          </a:effectRef>
-          <a:fontRef idx="minor">
-            <a:schemeClr val="lt1"/>
-          </a:fontRef>
-        </p:style>
-        <p:txBody>
-          <a:bodyPr rtlCol="0" anchor="ctr"/>
-          <a:lstStyle/>
-          <a:p>
-            <a:pPr algn="ctr"/>
-          </a:p>
-        </p:txBody>
-      </p:sp>
-      <p:sp>
-        <p:nvSpPr>
-          <p:cNvPr id="105" name="TextBox 104"/>
-          <p:cNvSpPr txBox="1"/>
-          <p:nvPr/>
-        </p:nvSpPr>
-        <p:spPr>
-          <a:xfrm>
-            <a:off x="576072" y="1600200"/>
-            <a:ext cx="2231136" cy="329184"/>
-          </a:xfrm>
-          <a:prstGeom prst="rect">
-            <a:avLst/>
-          </a:prstGeom>
-          <a:noFill/>
-        </p:spPr>
-        <p:txBody>
-          <a:bodyPr wrap="square" lIns="54864" rIns="54864" tIns="27432" bIns="0">
-            <a:spAutoFit/>
-          </a:bodyPr>
-          <a:lstStyle/>
-          <a:p>
-            <a:pPr>
-              <a:spcAft>
-                <a:spcPts val="700"/>
-              </a:spcAft>
-              <a:defRPr sz="1500" b="1">
-                <a:solidFill>
-                  <a:srgbClr val="1A73E8"/>
-                </a:solidFill>
-                <a:latin typeface="Arial"/>
-              </a:defRPr>
-            </a:pPr>
-            <a:r>
-              <a:t>Conversation</a:t>
-            </a:r>
-          </a:p>
-        </p:txBody>
-      </p:sp>
-      <p:sp>
-        <p:nvSpPr>
-          <p:cNvPr id="106" name="TextBox 105"/>
-          <p:cNvSpPr txBox="1"/>
-          <p:nvPr/>
-        </p:nvSpPr>
-        <p:spPr>
-          <a:xfrm>
-            <a:off x="576072" y="1993391"/>
-            <a:ext cx="2231136" cy="2039112"/>
-          </a:xfrm>
-          <a:prstGeom prst="rect">
-            <a:avLst/>
-          </a:prstGeom>
-          <a:noFill/>
-        </p:spPr>
-        <p:txBody>
-          <a:bodyPr wrap="square" lIns="54864" rIns="54864" tIns="27432" bIns="0">
-            <a:spAutoFit/>
-          </a:bodyPr>
-          <a:lstStyle/>
-          <a:p>
-            <a:pPr>
-              <a:spcAft>
-                <a:spcPts val="700"/>
-              </a:spcAft>
-              <a:defRPr sz="1300" b="0">
-                <a:solidFill>
-                  <a:srgbClr val="202124"/>
-                </a:solidFill>
-                <a:latin typeface="Arial"/>
-              </a:defRPr>
-            </a:pPr>
-            <a:r>
-              <a:t>Heard words</a:t>
-            </a:r>
-          </a:p>
-          <a:p>
-            <a:pPr>
-              <a:spcAft>
-                <a:spcPts val="700"/>
-              </a:spcAft>
-              <a:defRPr sz="1300" b="0">
-                <a:solidFill>
-                  <a:srgbClr val="202124"/>
-                </a:solidFill>
-                <a:latin typeface="Arial"/>
-              </a:defRPr>
-            </a:pPr>
-            <a:r>
-              <a:t>Meaning in your language</a:t>
-            </a:r>
-          </a:p>
-          <a:p>
-            <a:pPr>
-              <a:spcAft>
-                <a:spcPts val="700"/>
-              </a:spcAft>
-              <a:defRPr sz="1300" b="0">
-                <a:solidFill>
-                  <a:srgbClr val="202124"/>
-                </a:solidFill>
-                <a:latin typeface="Arial"/>
-              </a:defRPr>
-            </a:pPr>
-            <a:r>
-              <a:t>Three usable replies</a:t>
-            </a:r>
-          </a:p>
-          <a:p>
-            <a:pPr>
-              <a:spcAft>
-                <a:spcPts val="700"/>
-              </a:spcAft>
-              <a:defRPr sz="1300" b="0">
-                <a:solidFill>
-                  <a:srgbClr val="202124"/>
-                </a:solidFill>
-                <a:latin typeface="Arial"/>
-              </a:defRPr>
-            </a:pPr>
-            <a:r>
-              <a:t>Original / Pronunciation</a:t>
-            </a:r>
-          </a:p>
-          <a:p>
-            <a:pPr>
-              <a:spcAft>
-                <a:spcPts val="700"/>
-              </a:spcAft>
-              <a:defRPr sz="1300" b="0">
-                <a:solidFill>
-                  <a:srgbClr val="202124"/>
-                </a:solidFill>
-                <a:latin typeface="Arial"/>
-              </a:defRPr>
-            </a:pPr>
-            <a:r>
-              <a:t>Large listen button</a:t>
-            </a:r>
-          </a:p>
-        </p:txBody>
-      </p:sp>
-      <p:sp>
-        <p:nvSpPr>
-          <p:cNvPr id="107" name="Rounded Rectangle 106"/>
-          <p:cNvSpPr/>
-          <p:nvPr/>
-        </p:nvSpPr>
-        <p:spPr>
-          <a:xfrm>
-            <a:off x="3337560" y="1508760"/>
-            <a:ext cx="2468880" cy="2560320"/>
-          </a:xfrm>
-          <a:prstGeom prst="roundRect">
-            <a:avLst/>
-          </a:prstGeom>
-          <a:solidFill>
-            <a:srgbClr val="F1F6FD"/>
-          </a:solidFill>
-          <a:ln>
-            <a:solidFill>
-              <a:srgbClr val="DADCE0"/>
-            </a:solidFill>
-          </a:ln>
-        </p:spPr>
-        <p:style>
-          <a:lnRef idx="1">
-            <a:schemeClr val="accent1"/>
-          </a:lnRef>
-          <a:fillRef idx="3">
-            <a:schemeClr val="accent1"/>
-          </a:fillRef>
-          <a:effectRef idx="2">
-            <a:schemeClr val="accent1"/>
-          </a:effectRef>
-          <a:fontRef idx="minor">
-            <a:schemeClr val="lt1"/>
-          </a:fontRef>
-        </p:style>
-        <p:txBody>
-          <a:bodyPr rtlCol="0" anchor="ctr"/>
-          <a:lstStyle/>
-          <a:p>
-            <a:pPr algn="ctr"/>
-          </a:p>
-        </p:txBody>
-      </p:sp>
-      <p:sp>
-        <p:nvSpPr>
-          <p:cNvPr id="108" name="TextBox 107"/>
-          <p:cNvSpPr txBox="1"/>
-          <p:nvPr/>
-        </p:nvSpPr>
-        <p:spPr>
-          <a:xfrm>
-            <a:off x="3456432" y="1600200"/>
-            <a:ext cx="2231136" cy="329184"/>
-          </a:xfrm>
-          <a:prstGeom prst="rect">
-            <a:avLst/>
-          </a:prstGeom>
-          <a:noFill/>
-        </p:spPr>
-        <p:txBody>
-          <a:bodyPr wrap="square" lIns="54864" rIns="54864" tIns="27432" bIns="0">
-            <a:spAutoFit/>
-          </a:bodyPr>
-          <a:lstStyle/>
-          <a:p>
-            <a:pPr>
-              <a:spcAft>
-                <a:spcPts val="700"/>
-              </a:spcAft>
-              <a:defRPr sz="1500" b="1">
-                <a:solidFill>
-                  <a:srgbClr val="1A73E8"/>
-                </a:solidFill>
-                <a:latin typeface="Arial"/>
-              </a:defRPr>
-            </a:pPr>
-            <a:r>
-              <a:t>Before the task</a:t>
-            </a:r>
-          </a:p>
-        </p:txBody>
-      </p:sp>
-      <p:sp>
-        <p:nvSpPr>
-          <p:cNvPr id="109" name="TextBox 108"/>
-          <p:cNvSpPr txBox="1"/>
-          <p:nvPr/>
-        </p:nvSpPr>
-        <p:spPr>
-          <a:xfrm>
-            <a:off x="3456432" y="1993391"/>
-            <a:ext cx="2231136" cy="2039112"/>
-          </a:xfrm>
-          <a:prstGeom prst="rect">
-            <a:avLst/>
-          </a:prstGeom>
-          <a:noFill/>
-        </p:spPr>
-        <p:txBody>
-          <a:bodyPr wrap="square" lIns="54864" rIns="54864" tIns="27432" bIns="0">
-            <a:spAutoFit/>
-          </a:bodyPr>
-          <a:lstStyle/>
-          <a:p>
-            <a:pPr>
-              <a:spcAft>
-                <a:spcPts val="700"/>
-              </a:spcAft>
-              <a:defRPr sz="1300" b="0">
-                <a:solidFill>
-                  <a:srgbClr val="202124"/>
-                </a:solidFill>
-                <a:latin typeface="Arial"/>
-              </a:defRPr>
-            </a:pPr>
-            <a:r>
-              <a:t>Where do you want to go?</a:t>
-            </a:r>
-          </a:p>
-          <a:p>
-            <a:pPr>
-              <a:spcAft>
-                <a:spcPts val="700"/>
-              </a:spcAft>
-              <a:defRPr sz="1300" b="0">
-                <a:solidFill>
-                  <a:srgbClr val="202124"/>
-                </a:solidFill>
-                <a:latin typeface="Arial"/>
-              </a:defRPr>
-            </a:pPr>
-            <a:r>
-              <a:t>Optional stops</a:t>
-            </a:r>
-          </a:p>
-          <a:p>
-            <a:pPr>
-              <a:spcAft>
-                <a:spcPts val="700"/>
-              </a:spcAft>
-              <a:defRPr sz="1300" b="0">
-                <a:solidFill>
-                  <a:srgbClr val="202124"/>
-                </a:solidFill>
-                <a:latin typeface="Arial"/>
-              </a:defRPr>
-            </a:pPr>
-            <a:r>
-              <a:t>Learner-controlled progress</a:t>
-            </a:r>
-          </a:p>
-          <a:p>
-            <a:pPr>
-              <a:spcAft>
-                <a:spcPts val="700"/>
-              </a:spcAft>
-              <a:defRPr sz="1300" b="0">
-                <a:solidFill>
-                  <a:srgbClr val="202124"/>
-                </a:solidFill>
-                <a:latin typeface="Arial"/>
-              </a:defRPr>
-            </a:pPr>
-            <a:r>
-              <a:t>Relevant local memories</a:t>
-            </a:r>
-          </a:p>
-        </p:txBody>
-      </p:sp>
-      <p:sp>
-        <p:nvSpPr>
-          <p:cNvPr id="110" name="Rounded Rectangle 109"/>
-          <p:cNvSpPr/>
-          <p:nvPr/>
-        </p:nvSpPr>
-        <p:spPr>
-          <a:xfrm>
-            <a:off x="6217920" y="1508760"/>
-            <a:ext cx="2468880" cy="2560320"/>
-          </a:xfrm>
-          <a:prstGeom prst="roundRect">
-            <a:avLst/>
-          </a:prstGeom>
-          <a:solidFill>
-            <a:srgbClr val="F1F6FD"/>
-          </a:solidFill>
-          <a:ln>
-            <a:solidFill>
-              <a:srgbClr val="DADCE0"/>
-            </a:solidFill>
-          </a:ln>
-        </p:spPr>
-        <p:style>
-          <a:lnRef idx="1">
-            <a:schemeClr val="accent1"/>
-          </a:lnRef>
-          <a:fillRef idx="3">
-            <a:schemeClr val="accent1"/>
-          </a:fillRef>
-          <a:effectRef idx="2">
-            <a:schemeClr val="accent1"/>
-          </a:effectRef>
-          <a:fontRef idx="minor">
-            <a:schemeClr val="lt1"/>
-          </a:fontRef>
-        </p:style>
-        <p:txBody>
-          <a:bodyPr rtlCol="0" anchor="ctr"/>
-          <a:lstStyle/>
-          <a:p>
-            <a:pPr algn="ctr"/>
-          </a:p>
-        </p:txBody>
-      </p:sp>
-      <p:sp>
-        <p:nvSpPr>
-          <p:cNvPr id="111" name="TextBox 110"/>
-          <p:cNvSpPr txBox="1"/>
-          <p:nvPr/>
-        </p:nvSpPr>
-        <p:spPr>
-          <a:xfrm>
-            <a:off x="6336792" y="1600200"/>
-            <a:ext cx="2231136" cy="329184"/>
-          </a:xfrm>
-          <a:prstGeom prst="rect">
-            <a:avLst/>
-          </a:prstGeom>
-          <a:noFill/>
-        </p:spPr>
-        <p:txBody>
-          <a:bodyPr wrap="square" lIns="54864" rIns="54864" tIns="27432" bIns="0">
-            <a:spAutoFit/>
-          </a:bodyPr>
-          <a:lstStyle/>
-          <a:p>
-            <a:pPr>
-              <a:spcAft>
-                <a:spcPts val="700"/>
-              </a:spcAft>
-              <a:defRPr sz="1500" b="1">
-                <a:solidFill>
-                  <a:srgbClr val="1A73E8"/>
-                </a:solidFill>
-                <a:latin typeface="Arial"/>
-              </a:defRPr>
-            </a:pPr>
-            <a:r>
-              <a:t>Saved learning</a:t>
-            </a:r>
-          </a:p>
-        </p:txBody>
-      </p:sp>
-      <p:sp>
-        <p:nvSpPr>
-          <p:cNvPr id="112" name="TextBox 111"/>
-          <p:cNvSpPr txBox="1"/>
-          <p:nvPr/>
-        </p:nvSpPr>
-        <p:spPr>
-          <a:xfrm>
-            <a:off x="6336792" y="1993391"/>
-            <a:ext cx="2231136" cy="2039112"/>
-          </a:xfrm>
-          <a:prstGeom prst="rect">
-            <a:avLst/>
-          </a:prstGeom>
-          <a:noFill/>
-        </p:spPr>
-        <p:txBody>
-          <a:bodyPr wrap="square" lIns="54864" rIns="54864" tIns="27432" bIns="0">
-            <a:spAutoFit/>
-          </a:bodyPr>
-          <a:lstStyle/>
-          <a:p>
-            <a:pPr>
-              <a:spcAft>
-                <a:spcPts val="700"/>
-              </a:spcAft>
-              <a:defRPr sz="1300" b="0">
-                <a:solidFill>
-                  <a:srgbClr val="202124"/>
-                </a:solidFill>
-                <a:latin typeface="Arial"/>
-              </a:defRPr>
-            </a:pPr>
-            <a:r>
-              <a:t>Your conversation library</a:t>
-            </a:r>
-          </a:p>
-          <a:p>
-            <a:pPr>
-              <a:spcAft>
-                <a:spcPts val="700"/>
-              </a:spcAft>
-              <a:defRPr sz="1300" b="0">
-                <a:solidFill>
-                  <a:srgbClr val="202124"/>
-                </a:solidFill>
-                <a:latin typeface="Arial"/>
-              </a:defRPr>
-            </a:pPr>
-            <a:r>
-              <a:t>Tap a word → meaning</a:t>
-            </a:r>
-          </a:p>
-          <a:p>
-            <a:pPr>
-              <a:spcAft>
-                <a:spcPts val="700"/>
-              </a:spcAft>
-              <a:defRPr sz="1300" b="0">
-                <a:solidFill>
-                  <a:srgbClr val="202124"/>
-                </a:solidFill>
-                <a:latin typeface="Arial"/>
-              </a:defRPr>
-            </a:pPr>
-            <a:r>
-              <a:t>Pronunciation and practice</a:t>
-            </a:r>
-          </a:p>
-          <a:p>
-            <a:pPr>
-              <a:spcAft>
-                <a:spcPts val="700"/>
-              </a:spcAft>
-              <a:defRPr sz="1300" b="0">
-                <a:solidFill>
-                  <a:srgbClr val="202124"/>
-                </a:solidFill>
-                <a:latin typeface="Arial"/>
-              </a:defRPr>
-            </a:pPr>
-            <a:r>
-              <a:t>No new lesson request</a:t>
-            </a:r>
-          </a:p>
-        </p:txBody>
-      </p:sp>
-      <p:sp>
-        <p:nvSpPr>
-          <p:cNvPr id="113" name="TextBox 112"/>
-          <p:cNvSpPr txBox="1"/>
-          <p:nvPr/>
-        </p:nvSpPr>
-        <p:spPr>
-          <a:xfrm>
-            <a:off x="502920" y="4389120"/>
-            <a:ext cx="8046720" cy="274320"/>
-          </a:xfrm>
-          <a:prstGeom prst="rect">
-            <a:avLst/>
-          </a:prstGeom>
-          <a:noFill/>
-        </p:spPr>
-        <p:txBody>
-          <a:bodyPr wrap="square" lIns="54864" rIns="54864" tIns="27432" bIns="0">
-            <a:spAutoFit/>
-          </a:bodyPr>
-          <a:lstStyle/>
-          <a:p>
-            <a:pPr>
-              <a:spcAft>
-                <a:spcPts val="700"/>
-              </a:spcAft>
-              <a:defRPr sz="1200" b="0">
-                <a:solidFill>
-                  <a:srgbClr val="5F6368"/>
-                </a:solidFill>
-                <a:latin typeface="Arial"/>
-              </a:defRPr>
-            </a:pPr>
-            <a:r>
-              <a:t>Functional prototype screens are shown in the snapshots section and video.</a:t>
-            </a:r>
-          </a:p>
-        </p:txBody>
-      </p:sp>
-      <p:sp>
-        <p:nvSpPr>
-          <p:cNvPr id="114" name="TextBox 113"/>
+          <p:cNvPr id="104" name="TextBox 103"/>
           <p:cNvSpPr txBox="1"/>
           <p:nvPr/>
         </p:nvSpPr>
@@ -13733,687 +13331,33 @@
           </a:p>
         </p:txBody>
       </p:sp>
-      <p:sp>
-        <p:nvSpPr>
-          <p:cNvPr id="112" name="Rounded Rectangle 111"/>
-          <p:cNvSpPr/>
-          <p:nvPr/>
-        </p:nvSpPr>
-        <p:spPr>
-          <a:xfrm>
-            <a:off x="457200" y="1463040"/>
-            <a:ext cx="2423160" cy="2560320"/>
-          </a:xfrm>
-          <a:prstGeom prst="roundRect">
-            <a:avLst/>
-          </a:prstGeom>
-          <a:solidFill>
-            <a:srgbClr val="F1F6FD"/>
-          </a:solidFill>
-          <a:ln>
-            <a:solidFill>
-              <a:srgbClr val="DADCE0"/>
-            </a:solidFill>
-          </a:ln>
-        </p:spPr>
-        <p:style>
-          <a:lnRef idx="1">
-            <a:schemeClr val="accent1"/>
-          </a:lnRef>
-          <a:fillRef idx="3">
-            <a:schemeClr val="accent1"/>
-          </a:fillRef>
-          <a:effectRef idx="2">
-            <a:schemeClr val="accent1"/>
-          </a:effectRef>
-          <a:fontRef idx="minor">
-            <a:schemeClr val="lt1"/>
-          </a:fontRef>
-        </p:style>
-        <p:txBody>
-          <a:bodyPr rtlCol="0" anchor="ctr"/>
-          <a:lstStyle/>
-          <a:p>
-            <a:pPr algn="ctr"/>
-          </a:p>
-        </p:txBody>
-      </p:sp>
+      <p:pic>
+        <p:nvPicPr>
+          <p:cNvPr id="112" name="Picture 111" descr="architecture.png"/>
+          <p:cNvPicPr>
+            <a:picLocks noChangeAspect="1"/>
+          </p:cNvPicPr>
+          <p:nvPr/>
+        </p:nvPicPr>
+        <p:blipFill>
+          <a:blip r:embed="rId5"/>
+          <a:stretch>
+            <a:fillRect/>
+          </a:stretch>
+        </p:blipFill>
+        <p:spPr>
+          <a:xfrm>
+            <a:off x="457200" y="1280160"/>
+            <a:ext cx="8229600" cy="3486150"/>
+          </a:xfrm>
+          <a:prstGeom prst="rect">
+            <a:avLst/>
+          </a:prstGeom>
+        </p:spPr>
+      </p:pic>
       <p:sp>
         <p:nvSpPr>
           <p:cNvPr id="113" name="TextBox 112"/>
-          <p:cNvSpPr txBox="1"/>
-          <p:nvPr/>
-        </p:nvSpPr>
-        <p:spPr>
-          <a:xfrm>
-            <a:off x="576072" y="1554480"/>
-            <a:ext cx="2185415" cy="329184"/>
-          </a:xfrm>
-          <a:prstGeom prst="rect">
-            <a:avLst/>
-          </a:prstGeom>
-          <a:noFill/>
-        </p:spPr>
-        <p:txBody>
-          <a:bodyPr wrap="square" lIns="54864" rIns="54864" tIns="27432" bIns="0">
-            <a:spAutoFit/>
-          </a:bodyPr>
-          <a:lstStyle/>
-          <a:p>
-            <a:pPr>
-              <a:spcAft>
-                <a:spcPts val="700"/>
-              </a:spcAft>
-              <a:defRPr sz="1500" b="1">
-                <a:solidFill>
-                  <a:srgbClr val="1A73E8"/>
-                </a:solidFill>
-                <a:latin typeface="Arial"/>
-              </a:defRPr>
-            </a:pPr>
-            <a:r>
-              <a:t>Browser</a:t>
-            </a:r>
-          </a:p>
-        </p:txBody>
-      </p:sp>
-      <p:sp>
-        <p:nvSpPr>
-          <p:cNvPr id="114" name="TextBox 113"/>
-          <p:cNvSpPr txBox="1"/>
-          <p:nvPr/>
-        </p:nvSpPr>
-        <p:spPr>
-          <a:xfrm>
-            <a:off x="576072" y="1947672"/>
-            <a:ext cx="2185415" cy="2039112"/>
-          </a:xfrm>
-          <a:prstGeom prst="rect">
-            <a:avLst/>
-          </a:prstGeom>
-          <a:noFill/>
-        </p:spPr>
-        <p:txBody>
-          <a:bodyPr wrap="square" lIns="54864" rIns="54864" tIns="27432" bIns="0">
-            <a:spAutoFit/>
-          </a:bodyPr>
-          <a:lstStyle/>
-          <a:p>
-            <a:pPr>
-              <a:spcAft>
-                <a:spcPts val="700"/>
-              </a:spcAft>
-              <a:defRPr sz="1300" b="0">
-                <a:solidFill>
-                  <a:srgbClr val="202124"/>
-                </a:solidFill>
-                <a:latin typeface="Arial"/>
-              </a:defRPr>
-            </a:pPr>
-            <a:r>
-              <a:t>AudioWorklet capture</a:t>
-            </a:r>
-          </a:p>
-          <a:p>
-            <a:pPr>
-              <a:spcAft>
-                <a:spcPts val="700"/>
-              </a:spcAft>
-              <a:defRPr sz="1300" b="0">
-                <a:solidFill>
-                  <a:srgbClr val="202124"/>
-                </a:solidFill>
-                <a:latin typeface="Arial"/>
-              </a:defRPr>
-            </a:pPr>
-            <a:r>
-              <a:t>Local repeat / voice guard</a:t>
-            </a:r>
-          </a:p>
-          <a:p>
-            <a:pPr>
-              <a:spcAft>
-                <a:spcPts val="700"/>
-              </a:spcAft>
-              <a:defRPr sz="1300" b="0">
-                <a:solidFill>
-                  <a:srgbClr val="202124"/>
-                </a:solidFill>
-                <a:latin typeface="Arial"/>
-              </a:defRPr>
-            </a:pPr>
-            <a:r>
-              <a:t>Conversation + plan context</a:t>
-            </a:r>
-          </a:p>
-          <a:p>
-            <a:pPr>
-              <a:spcAft>
-                <a:spcPts val="700"/>
-              </a:spcAft>
-              <a:defRPr sz="1300" b="0">
-                <a:solidFill>
-                  <a:srgbClr val="202124"/>
-                </a:solidFill>
-                <a:latin typeface="Arial"/>
-              </a:defRPr>
-            </a:pPr>
-            <a:r>
-              <a:t>IndexedDB saved lessons</a:t>
-            </a:r>
-          </a:p>
-          <a:p>
-            <a:pPr>
-              <a:spcAft>
-                <a:spcPts val="700"/>
-              </a:spcAft>
-              <a:defRPr sz="1300" b="0">
-                <a:solidFill>
-                  <a:srgbClr val="202124"/>
-                </a:solidFill>
-                <a:latin typeface="Arial"/>
-              </a:defRPr>
-            </a:pPr>
-            <a:r>
-              <a:t>Local, opt-in place memory</a:t>
-            </a:r>
-          </a:p>
-        </p:txBody>
-      </p:sp>
-      <p:sp>
-        <p:nvSpPr>
-          <p:cNvPr id="115" name="Rounded Rectangle 114"/>
-          <p:cNvSpPr/>
-          <p:nvPr/>
-        </p:nvSpPr>
-        <p:spPr>
-          <a:xfrm>
-            <a:off x="3337560" y="1463040"/>
-            <a:ext cx="2423160" cy="2560320"/>
-          </a:xfrm>
-          <a:prstGeom prst="roundRect">
-            <a:avLst/>
-          </a:prstGeom>
-          <a:solidFill>
-            <a:srgbClr val="F1F6FD"/>
-          </a:solidFill>
-          <a:ln>
-            <a:solidFill>
-              <a:srgbClr val="DADCE0"/>
-            </a:solidFill>
-          </a:ln>
-        </p:spPr>
-        <p:style>
-          <a:lnRef idx="1">
-            <a:schemeClr val="accent1"/>
-          </a:lnRef>
-          <a:fillRef idx="3">
-            <a:schemeClr val="accent1"/>
-          </a:fillRef>
-          <a:effectRef idx="2">
-            <a:schemeClr val="accent1"/>
-          </a:effectRef>
-          <a:fontRef idx="minor">
-            <a:schemeClr val="lt1"/>
-          </a:fontRef>
-        </p:style>
-        <p:txBody>
-          <a:bodyPr rtlCol="0" anchor="ctr"/>
-          <a:lstStyle/>
-          <a:p>
-            <a:pPr algn="ctr"/>
-          </a:p>
-        </p:txBody>
-      </p:sp>
-      <p:sp>
-        <p:nvSpPr>
-          <p:cNvPr id="116" name="TextBox 115"/>
-          <p:cNvSpPr txBox="1"/>
-          <p:nvPr/>
-        </p:nvSpPr>
-        <p:spPr>
-          <a:xfrm>
-            <a:off x="3456432" y="1554480"/>
-            <a:ext cx="2185415" cy="329184"/>
-          </a:xfrm>
-          <a:prstGeom prst="rect">
-            <a:avLst/>
-          </a:prstGeom>
-          <a:noFill/>
-        </p:spPr>
-        <p:txBody>
-          <a:bodyPr wrap="square" lIns="54864" rIns="54864" tIns="27432" bIns="0">
-            <a:spAutoFit/>
-          </a:bodyPr>
-          <a:lstStyle/>
-          <a:p>
-            <a:pPr>
-              <a:spcAft>
-                <a:spcPts val="700"/>
-              </a:spcAft>
-              <a:defRPr sz="1500" b="1">
-                <a:solidFill>
-                  <a:srgbClr val="1A73E8"/>
-                </a:solidFill>
-                <a:latin typeface="Arial"/>
-              </a:defRPr>
-            </a:pPr>
-            <a:r>
-              <a:t>Google Cloud Run</a:t>
-            </a:r>
-          </a:p>
-        </p:txBody>
-      </p:sp>
-      <p:sp>
-        <p:nvSpPr>
-          <p:cNvPr id="117" name="TextBox 116"/>
-          <p:cNvSpPr txBox="1"/>
-          <p:nvPr/>
-        </p:nvSpPr>
-        <p:spPr>
-          <a:xfrm>
-            <a:off x="3456432" y="1947672"/>
-            <a:ext cx="2185415" cy="2039112"/>
-          </a:xfrm>
-          <a:prstGeom prst="rect">
-            <a:avLst/>
-          </a:prstGeom>
-          <a:noFill/>
-        </p:spPr>
-        <p:txBody>
-          <a:bodyPr wrap="square" lIns="54864" rIns="54864" tIns="27432" bIns="0">
-            <a:spAutoFit/>
-          </a:bodyPr>
-          <a:lstStyle/>
-          <a:p>
-            <a:pPr>
-              <a:spcAft>
-                <a:spcPts val="700"/>
-              </a:spcAft>
-              <a:defRPr sz="1300" b="0">
-                <a:solidFill>
-                  <a:srgbClr val="202124"/>
-                </a:solidFill>
-                <a:latin typeface="Arial"/>
-              </a:defRPr>
-            </a:pPr>
-            <a:r>
-              <a:t>FastAPI HTTP + WebSocket</a:t>
-            </a:r>
-          </a:p>
-          <a:p>
-            <a:pPr>
-              <a:spcAft>
-                <a:spcPts val="700"/>
-              </a:spcAft>
-              <a:defRPr sz="1300" b="0">
-                <a:solidFill>
-                  <a:srgbClr val="202124"/>
-                </a:solidFill>
-                <a:latin typeface="Arial"/>
-              </a:defRPr>
-            </a:pPr>
-            <a:r>
-              <a:t>Google / personal-key session</a:t>
-            </a:r>
-          </a:p>
-          <a:p>
-            <a:pPr>
-              <a:spcAft>
-                <a:spcPts val="700"/>
-              </a:spcAft>
-              <a:defRPr sz="1300" b="0">
-                <a:solidFill>
-                  <a:srgbClr val="202124"/>
-                </a:solidFill>
-                <a:latin typeface="Arial"/>
-              </a:defRPr>
-            </a:pPr>
-            <a:r>
-              <a:t>Request + audio quotas</a:t>
-            </a:r>
-          </a:p>
-          <a:p>
-            <a:pPr>
-              <a:spcAft>
-                <a:spcPts val="700"/>
-              </a:spcAft>
-              <a:defRPr sz="1300" b="0">
-                <a:solidFill>
-                  <a:srgbClr val="202124"/>
-                </a:solidFill>
-                <a:latin typeface="Arial"/>
-              </a:defRPr>
-            </a:pPr>
-            <a:r>
-              <a:t>Exact-source validation</a:t>
-            </a:r>
-          </a:p>
-          <a:p>
-            <a:pPr>
-              <a:spcAft>
-                <a:spcPts val="700"/>
-              </a:spcAft>
-              <a:defRPr sz="1300" b="0">
-                <a:solidFill>
-                  <a:srgbClr val="202124"/>
-                </a:solidFill>
-                <a:latin typeface="Arial"/>
-              </a:defRPr>
-            </a:pPr>
-            <a:r>
-              <a:t>Private durable daily quotas</a:t>
-            </a:r>
-          </a:p>
-        </p:txBody>
-      </p:sp>
-      <p:sp>
-        <p:nvSpPr>
-          <p:cNvPr id="118" name="Rounded Rectangle 117"/>
-          <p:cNvSpPr/>
-          <p:nvPr/>
-        </p:nvSpPr>
-        <p:spPr>
-          <a:xfrm>
-            <a:off x="6217920" y="1463040"/>
-            <a:ext cx="2423160" cy="2560320"/>
-          </a:xfrm>
-          <a:prstGeom prst="roundRect">
-            <a:avLst/>
-          </a:prstGeom>
-          <a:solidFill>
-            <a:srgbClr val="F1F6FD"/>
-          </a:solidFill>
-          <a:ln>
-            <a:solidFill>
-              <a:srgbClr val="DADCE0"/>
-            </a:solidFill>
-          </a:ln>
-        </p:spPr>
-        <p:style>
-          <a:lnRef idx="1">
-            <a:schemeClr val="accent1"/>
-          </a:lnRef>
-          <a:fillRef idx="3">
-            <a:schemeClr val="accent1"/>
-          </a:fillRef>
-          <a:effectRef idx="2">
-            <a:schemeClr val="accent1"/>
-          </a:effectRef>
-          <a:fontRef idx="minor">
-            <a:schemeClr val="lt1"/>
-          </a:fontRef>
-        </p:style>
-        <p:txBody>
-          <a:bodyPr rtlCol="0" anchor="ctr"/>
-          <a:lstStyle/>
-          <a:p>
-            <a:pPr algn="ctr"/>
-          </a:p>
-        </p:txBody>
-      </p:sp>
-      <p:sp>
-        <p:nvSpPr>
-          <p:cNvPr id="119" name="TextBox 118"/>
-          <p:cNvSpPr txBox="1"/>
-          <p:nvPr/>
-        </p:nvSpPr>
-        <p:spPr>
-          <a:xfrm>
-            <a:off x="6336792" y="1554480"/>
-            <a:ext cx="2185415" cy="329184"/>
-          </a:xfrm>
-          <a:prstGeom prst="rect">
-            <a:avLst/>
-          </a:prstGeom>
-          <a:noFill/>
-        </p:spPr>
-        <p:txBody>
-          <a:bodyPr wrap="square" lIns="54864" rIns="54864" tIns="27432" bIns="0">
-            <a:spAutoFit/>
-          </a:bodyPr>
-          <a:lstStyle/>
-          <a:p>
-            <a:pPr>
-              <a:spcAft>
-                <a:spcPts val="700"/>
-              </a:spcAft>
-              <a:defRPr sz="1500" b="1">
-                <a:solidFill>
-                  <a:srgbClr val="1A73E8"/>
-                </a:solidFill>
-                <a:latin typeface="Arial"/>
-              </a:defRPr>
-            </a:pPr>
-            <a:r>
-              <a:t>Google AI</a:t>
-            </a:r>
-          </a:p>
-        </p:txBody>
-      </p:sp>
-      <p:sp>
-        <p:nvSpPr>
-          <p:cNvPr id="120" name="TextBox 119"/>
-          <p:cNvSpPr txBox="1"/>
-          <p:nvPr/>
-        </p:nvSpPr>
-        <p:spPr>
-          <a:xfrm>
-            <a:off x="6336792" y="1947672"/>
-            <a:ext cx="2185415" cy="2039112"/>
-          </a:xfrm>
-          <a:prstGeom prst="rect">
-            <a:avLst/>
-          </a:prstGeom>
-          <a:noFill/>
-        </p:spPr>
-        <p:txBody>
-          <a:bodyPr wrap="square" lIns="54864" rIns="54864" tIns="27432" bIns="0">
-            <a:spAutoFit/>
-          </a:bodyPr>
-          <a:lstStyle/>
-          <a:p>
-            <a:pPr>
-              <a:spcAft>
-                <a:spcPts val="700"/>
-              </a:spcAft>
-              <a:defRPr sz="1300" b="0">
-                <a:solidFill>
-                  <a:srgbClr val="202124"/>
-                </a:solidFill>
-                <a:latin typeface="Arial"/>
-              </a:defRPr>
-            </a:pPr>
-            <a:r>
-              <a:t>Gemini 3.5 Transcribe Live</a:t>
-            </a:r>
-          </a:p>
-          <a:p>
-            <a:pPr>
-              <a:spcAft>
-                <a:spcPts val="700"/>
-              </a:spcAft>
-              <a:defRPr sz="1300" b="0">
-                <a:solidFill>
-                  <a:srgbClr val="202124"/>
-                </a:solidFill>
-                <a:latin typeface="Arial"/>
-              </a:defRPr>
-            </a:pPr>
-            <a:r>
-              <a:t>Gemini 3.1 Flash-Lite</a:t>
-            </a:r>
-          </a:p>
-          <a:p>
-            <a:pPr>
-              <a:spcAft>
-                <a:spcPts val="700"/>
-              </a:spcAft>
-              <a:defRPr sz="1300" b="0">
-                <a:solidFill>
-                  <a:srgbClr val="202124"/>
-                </a:solidFill>
-                <a:latin typeface="Arial"/>
-              </a:defRPr>
-            </a:pPr>
-            <a:r>
-              <a:t>Source and reply branches</a:t>
-            </a:r>
-          </a:p>
-          <a:p>
-            <a:pPr>
-              <a:spcAft>
-                <a:spcPts val="700"/>
-              </a:spcAft>
-              <a:defRPr sz="1300" b="0">
-                <a:solidFill>
-                  <a:srgbClr val="202124"/>
-                </a:solidFill>
-                <a:latin typeface="Arial"/>
-              </a:defRPr>
-            </a:pPr>
-            <a:r>
-              <a:t>Vertex service account</a:t>
-            </a:r>
-          </a:p>
-          <a:p>
-            <a:pPr>
-              <a:spcAft>
-                <a:spcPts val="700"/>
-              </a:spcAft>
-              <a:defRPr sz="1300" b="0">
-                <a:solidFill>
-                  <a:srgbClr val="202124"/>
-                </a:solidFill>
-                <a:latin typeface="Arial"/>
-              </a:defRPr>
-            </a:pPr>
-            <a:r>
-              <a:t>BYOK: Gemini Developer API</a:t>
-            </a:r>
-          </a:p>
-        </p:txBody>
-      </p:sp>
-      <p:sp>
-        <p:nvSpPr>
-          <p:cNvPr id="121" name="TextBox 120"/>
-          <p:cNvSpPr txBox="1"/>
-          <p:nvPr/>
-        </p:nvSpPr>
-        <p:spPr>
-          <a:xfrm>
-            <a:off x="2907792" y="2286000"/>
-            <a:ext cx="365760" cy="457200"/>
-          </a:xfrm>
-          <a:prstGeom prst="rect">
-            <a:avLst/>
-          </a:prstGeom>
-          <a:noFill/>
-        </p:spPr>
-        <p:txBody>
-          <a:bodyPr wrap="square" lIns="54864" rIns="54864" tIns="27432" bIns="0">
-            <a:spAutoFit/>
-          </a:bodyPr>
-          <a:lstStyle/>
-          <a:p>
-            <a:pPr>
-              <a:spcAft>
-                <a:spcPts val="700"/>
-              </a:spcAft>
-              <a:defRPr sz="2200" b="1">
-                <a:solidFill>
-                  <a:srgbClr val="1A73E8"/>
-                </a:solidFill>
-                <a:latin typeface="Arial"/>
-              </a:defRPr>
-            </a:pPr>
-            <a:r>
-              <a:t>⇄</a:t>
-            </a:r>
-          </a:p>
-        </p:txBody>
-      </p:sp>
-      <p:sp>
-        <p:nvSpPr>
-          <p:cNvPr id="122" name="TextBox 121"/>
-          <p:cNvSpPr txBox="1"/>
-          <p:nvPr/>
-        </p:nvSpPr>
-        <p:spPr>
-          <a:xfrm>
-            <a:off x="5779008" y="2286000"/>
-            <a:ext cx="365760" cy="457200"/>
-          </a:xfrm>
-          <a:prstGeom prst="rect">
-            <a:avLst/>
-          </a:prstGeom>
-          <a:noFill/>
-        </p:spPr>
-        <p:txBody>
-          <a:bodyPr wrap="square" lIns="54864" rIns="54864" tIns="27432" bIns="0">
-            <a:spAutoFit/>
-          </a:bodyPr>
-          <a:lstStyle/>
-          <a:p>
-            <a:pPr>
-              <a:spcAft>
-                <a:spcPts val="700"/>
-              </a:spcAft>
-              <a:defRPr sz="2200" b="1">
-                <a:solidFill>
-                  <a:srgbClr val="1A73E8"/>
-                </a:solidFill>
-                <a:latin typeface="Arial"/>
-              </a:defRPr>
-            </a:pPr>
-            <a:r>
-              <a:t>⇄</a:t>
-            </a:r>
-          </a:p>
-        </p:txBody>
-      </p:sp>
-      <p:sp>
-        <p:nvSpPr>
-          <p:cNvPr id="123" name="TextBox 122"/>
-          <p:cNvSpPr txBox="1"/>
-          <p:nvPr/>
-        </p:nvSpPr>
-        <p:spPr>
-          <a:xfrm>
-            <a:off x="502920" y="4297680"/>
-            <a:ext cx="8138160" cy="457200"/>
-          </a:xfrm>
-          <a:prstGeom prst="rect">
-            <a:avLst/>
-          </a:prstGeom>
-          <a:noFill/>
-        </p:spPr>
-        <p:txBody>
-          <a:bodyPr wrap="square" lIns="54864" rIns="54864" tIns="27432" bIns="0">
-            <a:spAutoFit/>
-          </a:bodyPr>
-          <a:lstStyle/>
-          <a:p>
-            <a:pPr>
-              <a:spcAft>
-                <a:spcPts val="700"/>
-              </a:spcAft>
-              <a:defRPr sz="1200" b="0">
-                <a:solidFill>
-                  <a:srgbClr val="5F6368"/>
-                </a:solidFill>
-                <a:latin typeface="Arial"/>
-              </a:defRPr>
-            </a:pPr>
-            <a:r>
-              <a:t>Firebase Authentication: Google sign-in. Private Cloud Storage: daily quotas. Firestore is not used; learning stays local.</a:t>
-            </a:r>
-          </a:p>
-        </p:txBody>
-      </p:sp>
-      <p:sp>
-        <p:nvSpPr>
-          <p:cNvPr id="124" name="TextBox 123"/>
           <p:cNvSpPr txBox="1"/>
           <p:nvPr/>
         </p:nvSpPr>
@@ -14691,7 +13635,7 @@
               </a:defRPr>
             </a:pPr>
             <a:r>
-              <a:t>Google AI</a:t>
+              <a:t>Live speech</a:t>
             </a:r>
           </a:p>
         </p:txBody>
@@ -14730,7 +13674,7 @@
               </a:defRPr>
             </a:pPr>
             <a:r>
-              <a:t>Gemini 3.5 Transcribe Live; two parallel Gemini 3.1 Flash-Lite branches with minimal thinking.</a:t>
+              <a:t>Gemini 3.5 Transcribe Live streams multilingual audio while the person speaks.</a:t>
             </a:r>
           </a:p>
         </p:txBody>
@@ -14814,7 +13758,7 @@
               </a:defRPr>
             </a:pPr>
             <a:r>
-              <a:t>Google Cloud</a:t>
+              <a:t>Fast, economical replies</a:t>
             </a:r>
           </a:p>
         </p:txBody>
@@ -14853,7 +13797,7 @@
               </a:defRPr>
             </a:pPr>
             <a:r>
-              <a:t>Firebase Authentication, Cloud Run, Vertex AI, private Cloud Storage and Secret Manager.</a:t>
+              <a:t>Two concurrent Gemini 3.1 Flash-Lite tasks: source understanding and reply generation; compact JSON.</a:t>
             </a:r>
           </a:p>
         </p:txBody>
@@ -14937,7 +13881,7 @@
               </a:defRPr>
             </a:pPr>
             <a:r>
-              <a:t>Web and backend</a:t>
+              <a:t>Google Cloud</a:t>
             </a:r>
           </a:p>
         </p:txBody>
@@ -14976,7 +13920,7 @@
               </a:defRPr>
             </a:pPr>
             <a:r>
-              <a:t>Responsive JavaScript PWA, AudioWorklet, IndexedDB, Python FastAPI and WebSockets.</a:t>
+              <a:t>Cloud Run + Vertex AI; Firebase Google sign-in; private Cloud Storage quotas; Secret Manager.</a:t>
             </a:r>
           </a:p>
         </p:txBody>
@@ -15060,7 +14004,7 @@
               </a:defRPr>
             </a:pPr>
             <a:r>
-              <a:t>Local adaptation</a:t>
+              <a:t>Local personalization</a:t>
             </a:r>
           </a:p>
         </p:txBody>
@@ -15099,7 +14043,7 @@
               </a:defRPr>
             </a:pPr>
             <a:r>
-              <a:t>Bounded context and lexical/acoustic heuristics; no model-weight fine-tuning or stored voiceprint.</a:t>
+              <a:t>IndexedDB lessons; editable learner profiles, task plans and guarded location-linked memory.</a:t>
             </a:r>
           </a:p>
         </p:txBody>

</xml_diff>

<commit_message>
Add proposed Starter and Plus plans and international migrant use cases
</commit_message>
<xml_diff>
--- a/docs/submission/LingoLive-Pitch-Deck.pptx
+++ b/docs/submission/LingoLive-Pitch-Deck.pptx
@@ -7168,7 +7168,7 @@
               </a:defRPr>
             </a:pPr>
             <a:r>
-              <a:t>~US$5 / learner / month · ₹450</a:t>
+              <a:t>Starter · US$5 / month</a:t>
             </a:r>
           </a:p>
         </p:txBody>
@@ -7207,7 +7207,7 @@
               </a:defRPr>
             </a:pPr>
             <a:r>
-              <a:t>200 listening minutes + 400 new reply turns per month.</a:t>
+              <a:t>120 listening minutes + 240 new reply turns; occasional everyday help.</a:t>
             </a:r>
           </a:p>
         </p:txBody>
@@ -7291,7 +7291,7 @@
               </a:defRPr>
             </a:pPr>
             <a:r>
-              <a:t>100 learners · ~US$465 / month</a:t>
+              <a:t>Plus · US$20 / month</a:t>
             </a:r>
           </a:p>
         </p:txBody>
@@ -7330,7 +7330,7 @@
               </a:defRPr>
             </a:pPr>
             <a:r>
-              <a:t>Shared community estimate, including contingency.</a:t>
+              <a:t>600 listening minutes + 1,200 new turns; frequent work and daily use.</a:t>
             </a:r>
           </a:p>
         </p:txBody>
@@ -7369,7 +7369,7 @@
               </a:defRPr>
             </a:pPr>
             <a:r>
-              <a:t>Per learner: speech $1.79 + generation $1.76 + shared infrastructure $0.30. Add 20% contingency, then round the budget to US$5.</a:t>
+              <a:t>Proposed subscriptions share the same core features. Estimated full-use operating expense: Starter US$2.91; Plus US$13.48 per member/month, including contingency.</a:t>
             </a:r>
           </a:p>
         </p:txBody>
@@ -7408,7 +7408,7 @@
               </a:defRPr>
             </a:pPr>
             <a:r>
-              <a:t>Usage estimate: 10 minutes and 20 new reply turns per day, on 20 days per month; hosting shared across 100 active learners. Each turn uses two parallel calls.</a:t>
+              <a:t>Both include contextual replies, pronunciation, plans, location-linked memory and saved learning. Plus offers five times the usage. Organizations can sponsor members or arrange group packages.</a:t>
             </a:r>
           </a:p>
         </p:txBody>
@@ -7447,7 +7447,7 @@
               </a:defRPr>
             </a:pPr>
             <a:r>
-              <a:t>Rate basis: Live Transcribe $0.008925/min; Flash-Lite $0.25/M input and $1.50/M output. Standard global rates checked 18 Oct 2026; before tax and credits. INR planning rate: ₹90/US$. Detailed assumptions: technical PDF.</a:t>
+              <a:t>Expense assumptions: 8,000 input / 1,600 output tokens across both calls per turn; shared hosting across 100 members; 20% contingency. Live speech $0.008925/min; Flash-Lite $0.25/M input and $1.50/M output. Detailed rates and assumptions: technical PDF.</a:t>
             </a:r>
           </a:p>
         </p:txBody>
@@ -8830,7 +8830,7 @@
               </a:defRPr>
             </a:pPr>
             <a:r>
-              <a:t>Adoption and business estimates</a:t>
+              <a:t>Proposed plans and growth</a:t>
             </a:r>
           </a:p>
         </p:txBody>
@@ -8869,7 +8869,7 @@
               </a:defRPr>
             </a:pPr>
             <a:r>
-              <a:t>20 partners × 100 learners = 2,000 learners.</a:t>
+              <a:t>Starter US$5; Plus US$20 per month.</a:t>
             </a:r>
           </a:p>
           <a:p>
@@ -8885,7 +8885,7 @@
               </a:defRPr>
             </a:pPr>
             <a:r>
-              <a:t>Community-sponsored usage packages.</a:t>
+              <a:t>Community and employer-sponsored packages.</a:t>
             </a:r>
           </a:p>
           <a:p>
@@ -8901,7 +8901,7 @@
               </a:defRPr>
             </a:pPr>
             <a:r>
-              <a:t>Estimated operating budget: ~US$5 / active learner / month in a 100-member community.</a:t>
+              <a:t>20 partners × 100 learners = 2,000 learners.</a:t>
             </a:r>
           </a:p>
           <a:p>
@@ -8917,7 +8917,7 @@
               </a:defRPr>
             </a:pPr>
             <a:r>
-              <a:t>Partners: migrant groups, NGOs, campuses and employers globally.</a:t>
+              <a:t>Illustrative 80% Starter / 20% Plus mix: US$16,000 monthly revenue.</a:t>
             </a:r>
           </a:p>
         </p:txBody>
@@ -9001,7 +9001,7 @@
               </a:defRPr>
             </a:pPr>
             <a:r>
-              <a:t>Pilot targets and next delivery</a:t>
+              <a:t>International rollout</a:t>
             </a:r>
           </a:p>
         </p:txBody>
@@ -9040,7 +9040,7 @@
               </a:defRPr>
             </a:pPr>
             <a:r>
-              <a:t>Four weeks, 50 learners: ~1,600 encounters and 8,000 assisted turns.</a:t>
+              <a:t>Germany: German for transport, shopping, rental conversations and work.</a:t>
             </a:r>
           </a:p>
           <a:p>
@@ -9056,7 +9056,7 @@
               </a:defRPr>
             </a:pPr>
             <a:r>
-              <a:t>Targets: 70% useful reply sets; 80% task completion.</a:t>
+              <a:t>Japan: Japanese replies and Latin-script pronunciation for daily encounters.</a:t>
             </a:r>
           </a:p>
           <a:p>
@@ -9072,7 +9072,7 @@
               </a:defRPr>
             </a:pPr>
             <a:r>
-              <a:t>Next: more language pairs, partner allowances and opt-in local voice enrollment.</a:t>
+              <a:t>Language-pair review, local examples and migrant-community partnerships.</a:t>
             </a:r>
           </a:p>
         </p:txBody>
@@ -9111,7 +9111,7 @@
               </a:defRPr>
             </a:pPr>
             <a:r>
-              <a:t>Adoption, pilot outcomes and unit economics are planning estimates/targets; assumptions and scale scenario are in the technical PDF.</a:t>
+              <a:t>Prices and expansion are commercial proposals; revenue and expenses are scenario estimates. German and Japanese are already selectable.</a:t>
             </a:r>
           </a:p>
         </p:txBody>
@@ -10806,7 +10806,7 @@
               </a:defRPr>
             </a:pPr>
             <a:r>
-              <a:t>Interstate and international migrants. Customers: migrant associations, NGOs, universities, employers and relocation teams anywhere.</a:t>
+              <a:t>Newcomers in India, Germany, Japan and beyond. Customers: migrant groups, NGOs, universities, employers and relocation teams.</a:t>
             </a:r>
           </a:p>
         </p:txBody>

</xml_diff>